<commit_message>
Volle Eval-Matrix, Start-Pin fuer SVGD-Replanning, LSE-Debt-Fix und Optuna-Suche
- evaluation_full_matrix: vollstaendiger Lauf ueber alle Varianten x Holdout-Formen (Plots, Metriken, Rohdaten)
- svgd_refine/interactive_sim: Startpunkt-Pin fuer Replanning B/C/D, damit neu geplante Bahnen am zuletzt gefahrenen Punkt anschliessen
- apply_cfm_belief: eigenes, kleineres debt_weight_lse fuer --phi_model lse (verhindert falsches Unterschreiten von tau nach Besuch)
- interactive_sim: Optimal-Policy-Knopf zeigt ON/OFF und laesst sich erneut abschalten
- optuna_search.py: Bayessche Suche ueber den vollen Einstellungsraum der Laengeneinheit-Mission
- viz_path_distribution.py: Visualisierung der gelernten Pfadverteilung fuer eine Holdout-Form
</commit_message>
<xml_diff>
--- a/Meeting 23 notes.pptx
+++ b/Meeting 23 notes.pptx
@@ -258,7 +258,7 @@
           <a:p>
             <a:fld id="{FDDDB80F-6D04-40C9-AD9B-348CDB80E5D6}" type="datetimeFigureOut">
               <a:rPr lang="en-US" smtClean="0"/>
-              <a:t>7/23/2026</a:t>
+              <a:t>9/9/2026</a:t>
             </a:fld>
             <a:endParaRPr lang="en-US"/>
           </a:p>
@@ -428,7 +428,7 @@
           <a:p>
             <a:fld id="{FDDDB80F-6D04-40C9-AD9B-348CDB80E5D6}" type="datetimeFigureOut">
               <a:rPr lang="en-US" smtClean="0"/>
-              <a:t>7/23/2026</a:t>
+              <a:t>9/9/2026</a:t>
             </a:fld>
             <a:endParaRPr lang="en-US"/>
           </a:p>
@@ -608,7 +608,7 @@
           <a:p>
             <a:fld id="{FDDDB80F-6D04-40C9-AD9B-348CDB80E5D6}" type="datetimeFigureOut">
               <a:rPr lang="en-US" smtClean="0"/>
-              <a:t>7/23/2026</a:t>
+              <a:t>9/9/2026</a:t>
             </a:fld>
             <a:endParaRPr lang="en-US"/>
           </a:p>
@@ -778,7 +778,7 @@
           <a:p>
             <a:fld id="{FDDDB80F-6D04-40C9-AD9B-348CDB80E5D6}" type="datetimeFigureOut">
               <a:rPr lang="en-US" smtClean="0"/>
-              <a:t>7/23/2026</a:t>
+              <a:t>9/9/2026</a:t>
             </a:fld>
             <a:endParaRPr lang="en-US"/>
           </a:p>
@@ -1024,7 +1024,7 @@
           <a:p>
             <a:fld id="{FDDDB80F-6D04-40C9-AD9B-348CDB80E5D6}" type="datetimeFigureOut">
               <a:rPr lang="en-US" smtClean="0"/>
-              <a:t>7/23/2026</a:t>
+              <a:t>9/9/2026</a:t>
             </a:fld>
             <a:endParaRPr lang="en-US"/>
           </a:p>
@@ -1256,7 +1256,7 @@
           <a:p>
             <a:fld id="{FDDDB80F-6D04-40C9-AD9B-348CDB80E5D6}" type="datetimeFigureOut">
               <a:rPr lang="en-US" smtClean="0"/>
-              <a:t>7/23/2026</a:t>
+              <a:t>9/9/2026</a:t>
             </a:fld>
             <a:endParaRPr lang="en-US"/>
           </a:p>
@@ -1623,7 +1623,7 @@
           <a:p>
             <a:fld id="{FDDDB80F-6D04-40C9-AD9B-348CDB80E5D6}" type="datetimeFigureOut">
               <a:rPr lang="en-US" smtClean="0"/>
-              <a:t>7/23/2026</a:t>
+              <a:t>9/9/2026</a:t>
             </a:fld>
             <a:endParaRPr lang="en-US"/>
           </a:p>
@@ -1741,7 +1741,7 @@
           <a:p>
             <a:fld id="{FDDDB80F-6D04-40C9-AD9B-348CDB80E5D6}" type="datetimeFigureOut">
               <a:rPr lang="en-US" smtClean="0"/>
-              <a:t>7/23/2026</a:t>
+              <a:t>9/9/2026</a:t>
             </a:fld>
             <a:endParaRPr lang="en-US"/>
           </a:p>
@@ -1836,7 +1836,7 @@
           <a:p>
             <a:fld id="{FDDDB80F-6D04-40C9-AD9B-348CDB80E5D6}" type="datetimeFigureOut">
               <a:rPr lang="en-US" smtClean="0"/>
-              <a:t>7/23/2026</a:t>
+              <a:t>9/9/2026</a:t>
             </a:fld>
             <a:endParaRPr lang="en-US"/>
           </a:p>
@@ -2113,7 +2113,7 @@
           <a:p>
             <a:fld id="{FDDDB80F-6D04-40C9-AD9B-348CDB80E5D6}" type="datetimeFigureOut">
               <a:rPr lang="en-US" smtClean="0"/>
-              <a:t>7/23/2026</a:t>
+              <a:t>9/9/2026</a:t>
             </a:fld>
             <a:endParaRPr lang="en-US"/>
           </a:p>
@@ -2370,7 +2370,7 @@
           <a:p>
             <a:fld id="{FDDDB80F-6D04-40C9-AD9B-348CDB80E5D6}" type="datetimeFigureOut">
               <a:rPr lang="en-US" smtClean="0"/>
-              <a:t>7/23/2026</a:t>
+              <a:t>9/9/2026</a:t>
             </a:fld>
             <a:endParaRPr lang="en-US"/>
           </a:p>
@@ -2583,7 +2583,7 @@
           <a:p>
             <a:fld id="{FDDDB80F-6D04-40C9-AD9B-348CDB80E5D6}" type="datetimeFigureOut">
               <a:rPr lang="en-US" smtClean="0"/>
-              <a:t>7/23/2026</a:t>
+              <a:t>9/9/2026</a:t>
             </a:fld>
             <a:endParaRPr lang="en-US"/>
           </a:p>
@@ -3074,58 +3074,6 @@
       </p:grpSpPr>
       <p:sp>
         <p:nvSpPr>
-          <p:cNvPr id="65" name="Rectangle 64">
-            <a:extLst>
-              <a:ext uri="{FF2B5EF4-FFF2-40B4-BE49-F238E27FC236}">
-                <a16:creationId xmlns:a16="http://schemas.microsoft.com/office/drawing/2014/main" id="{01AF2AA7-E939-63CC-38CE-0F455AD5F781}"/>
-              </a:ext>
-            </a:extLst>
-          </p:cNvPr>
-          <p:cNvSpPr/>
-          <p:nvPr/>
-        </p:nvSpPr>
-        <p:spPr>
-          <a:xfrm>
-            <a:off x="8602980" y="6324600"/>
-            <a:ext cx="7254240" cy="4808220"/>
-          </a:xfrm>
-          <a:prstGeom prst="rect">
-            <a:avLst/>
-          </a:prstGeom>
-          <a:solidFill>
-            <a:schemeClr val="accent2">
-              <a:lumMod val="20000"/>
-              <a:lumOff val="80000"/>
-            </a:schemeClr>
-          </a:solidFill>
-        </p:spPr>
-        <p:style>
-          <a:lnRef idx="2">
-            <a:schemeClr val="accent1">
-              <a:shade val="15000"/>
-            </a:schemeClr>
-          </a:lnRef>
-          <a:fillRef idx="1">
-            <a:schemeClr val="accent1"/>
-          </a:fillRef>
-          <a:effectRef idx="0">
-            <a:schemeClr val="accent1"/>
-          </a:effectRef>
-          <a:fontRef idx="minor">
-            <a:schemeClr val="lt1"/>
-          </a:fontRef>
-        </p:style>
-        <p:txBody>
-          <a:bodyPr rtlCol="0" anchor="ctr"/>
-          <a:lstStyle/>
-          <a:p>
-            <a:pPr algn="ctr"/>
-            <a:endParaRPr lang="en-US"/>
-          </a:p>
-        </p:txBody>
-      </p:sp>
-      <p:sp>
-        <p:nvSpPr>
           <p:cNvPr id="2" name="Title 1">
             <a:extLst>
               <a:ext uri="{FF2B5EF4-FFF2-40B4-BE49-F238E27FC236}">
@@ -3153,1306 +3101,1379 @@
           </a:p>
         </p:txBody>
       </p:sp>
-      <p:sp>
-        <p:nvSpPr>
-          <p:cNvPr id="4" name="Rectangle 3">
+      <p:grpSp>
+        <p:nvGrpSpPr>
+          <p:cNvPr id="3" name="Group 2">
             <a:extLst>
               <a:ext uri="{FF2B5EF4-FFF2-40B4-BE49-F238E27FC236}">
-                <a16:creationId xmlns:a16="http://schemas.microsoft.com/office/drawing/2014/main" id="{70DC31C1-FA46-0D7F-E303-4BD17E035EC7}"/>
+                <a16:creationId xmlns:a16="http://schemas.microsoft.com/office/drawing/2014/main" id="{1341ADD4-B256-47A2-E4C0-FA672FFF2AF0}"/>
               </a:ext>
             </a:extLst>
           </p:cNvPr>
-          <p:cNvSpPr/>
+          <p:cNvGrpSpPr/>
           <p:nvPr/>
-        </p:nvSpPr>
-        <p:spPr>
+        </p:nvGrpSpPr>
+        <p:grpSpPr>
           <a:xfrm>
-            <a:off x="3971131" y="7528560"/>
-            <a:ext cx="4489450" cy="2652897"/>
+            <a:off x="2590005" y="6324600"/>
+            <a:ext cx="13267215" cy="6991719"/>
+            <a:chOff x="2590005" y="6324600"/>
+            <a:chExt cx="13267215" cy="6991719"/>
           </a:xfrm>
-          <a:prstGeom prst="rect">
-            <a:avLst/>
-          </a:prstGeom>
-        </p:spPr>
-        <p:style>
-          <a:lnRef idx="2">
-            <a:schemeClr val="accent4">
-              <a:shade val="15000"/>
-            </a:schemeClr>
-          </a:lnRef>
-          <a:fillRef idx="1">
-            <a:schemeClr val="accent4"/>
-          </a:fillRef>
-          <a:effectRef idx="0">
-            <a:schemeClr val="accent4"/>
-          </a:effectRef>
-          <a:fontRef idx="minor">
-            <a:schemeClr val="lt1"/>
-          </a:fontRef>
-        </p:style>
-        <p:txBody>
-          <a:bodyPr rtlCol="0" anchor="ctr"/>
-          <a:lstStyle/>
-          <a:p>
-            <a:pPr algn="ctr"/>
-            <a:endParaRPr lang="en-US" dirty="0"/>
-          </a:p>
-        </p:txBody>
-      </p:sp>
-      <p:sp>
-        <p:nvSpPr>
-          <p:cNvPr id="5" name="TextBox 4">
-            <a:extLst>
-              <a:ext uri="{FF2B5EF4-FFF2-40B4-BE49-F238E27FC236}">
-                <a16:creationId xmlns:a16="http://schemas.microsoft.com/office/drawing/2014/main" id="{3AE7CCFB-A858-9B6F-947E-A59670379913}"/>
-              </a:ext>
-            </a:extLst>
-          </p:cNvPr>
-          <p:cNvSpPr txBox="1"/>
-          <p:nvPr/>
-        </p:nvSpPr>
-        <p:spPr>
-          <a:xfrm>
-            <a:off x="4037649" y="7605132"/>
-            <a:ext cx="1606550" cy="2186496"/>
-          </a:xfrm>
-          <a:prstGeom prst="rect">
-            <a:avLst/>
-          </a:prstGeom>
-          <a:noFill/>
-        </p:spPr>
-        <p:txBody>
-          <a:bodyPr wrap="square" rtlCol="0">
-            <a:spAutoFit/>
-          </a:bodyPr>
-          <a:lstStyle/>
-          <a:p>
-            <a:r>
-              <a:rPr lang="de-DE" dirty="0"/>
-              <a:t>Data </a:t>
-            </a:r>
-            <a:r>
-              <a:rPr lang="de-DE" dirty="0" err="1"/>
-              <a:t>preprocessing</a:t>
-            </a:r>
-            <a:endParaRPr lang="en-US" dirty="0"/>
-          </a:p>
-        </p:txBody>
-      </p:sp>
-      <p:sp>
-        <p:nvSpPr>
-          <p:cNvPr id="7" name="TextBox 6">
-            <a:extLst>
-              <a:ext uri="{FF2B5EF4-FFF2-40B4-BE49-F238E27FC236}">
-                <a16:creationId xmlns:a16="http://schemas.microsoft.com/office/drawing/2014/main" id="{4A0C5739-595D-3E81-DD57-3725F7D75297}"/>
-              </a:ext>
-            </a:extLst>
-          </p:cNvPr>
-          <p:cNvSpPr txBox="1"/>
-          <p:nvPr/>
-        </p:nvSpPr>
-        <p:spPr>
-          <a:xfrm>
-            <a:off x="2590006" y="8395712"/>
-            <a:ext cx="1606550" cy="1139414"/>
-          </a:xfrm>
-          <a:prstGeom prst="rect">
-            <a:avLst/>
-          </a:prstGeom>
-          <a:noFill/>
-        </p:spPr>
-        <p:txBody>
-          <a:bodyPr wrap="square" rtlCol="0">
-            <a:spAutoFit/>
-          </a:bodyPr>
-          <a:lstStyle/>
-          <a:p>
-            <a:r>
-              <a:rPr lang="de-DE" dirty="0" err="1"/>
-              <a:t>Trajectory</a:t>
-            </a:r>
-            <a:endParaRPr lang="en-US" dirty="0"/>
-          </a:p>
-        </p:txBody>
-      </p:sp>
-      <p:sp>
-        <p:nvSpPr>
-          <p:cNvPr id="9" name="TextBox 8">
-            <a:extLst>
-              <a:ext uri="{FF2B5EF4-FFF2-40B4-BE49-F238E27FC236}">
-                <a16:creationId xmlns:a16="http://schemas.microsoft.com/office/drawing/2014/main" id="{F40563CF-072F-E4D6-903C-71F7AF434E24}"/>
-              </a:ext>
-            </a:extLst>
-          </p:cNvPr>
-          <p:cNvSpPr txBox="1"/>
-          <p:nvPr/>
-        </p:nvSpPr>
-        <p:spPr>
-          <a:xfrm>
-            <a:off x="2590006" y="9042043"/>
-            <a:ext cx="1606550" cy="1139414"/>
-          </a:xfrm>
-          <a:prstGeom prst="rect">
-            <a:avLst/>
-          </a:prstGeom>
-          <a:noFill/>
-        </p:spPr>
-        <p:txBody>
-          <a:bodyPr wrap="square" rtlCol="0">
-            <a:spAutoFit/>
-          </a:bodyPr>
-          <a:lstStyle/>
-          <a:p>
-            <a:r>
-              <a:rPr lang="de-DE" dirty="0"/>
-              <a:t>Flow Time</a:t>
-            </a:r>
-            <a:endParaRPr lang="en-US" dirty="0"/>
-          </a:p>
-        </p:txBody>
-      </p:sp>
-      <p:sp>
-        <p:nvSpPr>
-          <p:cNvPr id="11" name="TextBox 10">
-            <a:extLst>
-              <a:ext uri="{FF2B5EF4-FFF2-40B4-BE49-F238E27FC236}">
-                <a16:creationId xmlns:a16="http://schemas.microsoft.com/office/drawing/2014/main" id="{EBDC45EB-39EF-6615-63A5-F919F37261F5}"/>
-              </a:ext>
-            </a:extLst>
-          </p:cNvPr>
-          <p:cNvSpPr txBox="1"/>
-          <p:nvPr/>
-        </p:nvSpPr>
-        <p:spPr>
-          <a:xfrm>
-            <a:off x="2590005" y="9541450"/>
-            <a:ext cx="1606551" cy="646331"/>
-          </a:xfrm>
-          <a:prstGeom prst="rect">
-            <a:avLst/>
-          </a:prstGeom>
-          <a:noFill/>
-        </p:spPr>
-        <p:txBody>
-          <a:bodyPr wrap="square" rtlCol="0">
-            <a:spAutoFit/>
-          </a:bodyPr>
-          <a:lstStyle/>
-          <a:p>
-            <a:r>
-              <a:rPr lang="de-DE" dirty="0"/>
-              <a:t>Target </a:t>
-            </a:r>
-          </a:p>
-          <a:p>
-            <a:r>
-              <a:rPr lang="de-DE" dirty="0"/>
-              <a:t>Shape</a:t>
-            </a:r>
-            <a:endParaRPr lang="en-US" dirty="0"/>
-          </a:p>
-        </p:txBody>
-      </p:sp>
-      <p:sp>
-        <p:nvSpPr>
-          <p:cNvPr id="12" name="Rectangle: Rounded Corners 11">
-            <a:extLst>
-              <a:ext uri="{FF2B5EF4-FFF2-40B4-BE49-F238E27FC236}">
-                <a16:creationId xmlns:a16="http://schemas.microsoft.com/office/drawing/2014/main" id="{002551A4-7F36-810E-C8AB-CD2E41541AF8}"/>
-              </a:ext>
-            </a:extLst>
-          </p:cNvPr>
-          <p:cNvSpPr/>
-          <p:nvPr/>
-        </p:nvSpPr>
-        <p:spPr>
-          <a:xfrm>
-            <a:off x="4082258" y="8441531"/>
-            <a:ext cx="3095625" cy="453588"/>
-          </a:xfrm>
-          <a:prstGeom prst="roundRect">
-            <a:avLst/>
-          </a:prstGeom>
-        </p:spPr>
-        <p:style>
-          <a:lnRef idx="2">
-            <a:schemeClr val="accent4">
-              <a:shade val="15000"/>
-            </a:schemeClr>
-          </a:lnRef>
-          <a:fillRef idx="1">
-            <a:schemeClr val="accent4"/>
-          </a:fillRef>
-          <a:effectRef idx="0">
-            <a:schemeClr val="accent4"/>
-          </a:effectRef>
-          <a:fontRef idx="minor">
-            <a:schemeClr val="lt1"/>
-          </a:fontRef>
-        </p:style>
-        <p:txBody>
-          <a:bodyPr rtlCol="0" anchor="ctr"/>
-          <a:lstStyle/>
-          <a:p>
-            <a:pPr algn="ctr"/>
-            <a:r>
-              <a:rPr lang="de-DE" dirty="0" err="1"/>
-              <a:t>Convolutional</a:t>
-            </a:r>
-            <a:r>
-              <a:rPr lang="de-DE" dirty="0"/>
-              <a:t> </a:t>
-            </a:r>
-            <a:r>
-              <a:rPr lang="de-DE" dirty="0" err="1"/>
-              <a:t>encoding</a:t>
-            </a:r>
-            <a:endParaRPr lang="en-US" dirty="0"/>
-          </a:p>
-        </p:txBody>
-      </p:sp>
-      <p:sp>
-        <p:nvSpPr>
-          <p:cNvPr id="14" name="Rectangle: Rounded Corners 13">
-            <a:extLst>
-              <a:ext uri="{FF2B5EF4-FFF2-40B4-BE49-F238E27FC236}">
-                <a16:creationId xmlns:a16="http://schemas.microsoft.com/office/drawing/2014/main" id="{64294990-7F7B-F473-747B-8E46DE35AA70}"/>
-              </a:ext>
-            </a:extLst>
-          </p:cNvPr>
-          <p:cNvSpPr/>
-          <p:nvPr/>
-        </p:nvSpPr>
-        <p:spPr>
-          <a:xfrm>
-            <a:off x="4082258" y="9007802"/>
-            <a:ext cx="3095625" cy="453588"/>
-          </a:xfrm>
-          <a:prstGeom prst="roundRect">
-            <a:avLst/>
-          </a:prstGeom>
-        </p:spPr>
-        <p:style>
-          <a:lnRef idx="2">
-            <a:schemeClr val="accent4">
-              <a:shade val="15000"/>
-            </a:schemeClr>
-          </a:lnRef>
-          <a:fillRef idx="1">
-            <a:schemeClr val="accent4"/>
-          </a:fillRef>
-          <a:effectRef idx="0">
-            <a:schemeClr val="accent4"/>
-          </a:effectRef>
-          <a:fontRef idx="minor">
-            <a:schemeClr val="lt1"/>
-          </a:fontRef>
-        </p:style>
-        <p:txBody>
-          <a:bodyPr rtlCol="0" anchor="ctr"/>
-          <a:lstStyle/>
-          <a:p>
-            <a:pPr algn="ctr"/>
-            <a:r>
-              <a:rPr lang="de-DE" dirty="0" err="1"/>
-              <a:t>Sinusoidal</a:t>
-            </a:r>
-            <a:r>
-              <a:rPr lang="de-DE" dirty="0"/>
-              <a:t> Time </a:t>
-            </a:r>
-            <a:r>
-              <a:rPr lang="de-DE" dirty="0" err="1"/>
-              <a:t>embedding</a:t>
-            </a:r>
-            <a:endParaRPr lang="en-US" dirty="0"/>
-          </a:p>
-        </p:txBody>
-      </p:sp>
-      <p:sp>
-        <p:nvSpPr>
-          <p:cNvPr id="16" name="Rectangle: Rounded Corners 15">
-            <a:extLst>
-              <a:ext uri="{FF2B5EF4-FFF2-40B4-BE49-F238E27FC236}">
-                <a16:creationId xmlns:a16="http://schemas.microsoft.com/office/drawing/2014/main" id="{71F7D8A1-4909-A92A-67C4-B1214D3AC981}"/>
-              </a:ext>
-            </a:extLst>
-          </p:cNvPr>
-          <p:cNvSpPr/>
-          <p:nvPr/>
-        </p:nvSpPr>
-        <p:spPr>
-          <a:xfrm>
-            <a:off x="4082258" y="9591465"/>
-            <a:ext cx="3095625" cy="453588"/>
-          </a:xfrm>
-          <a:prstGeom prst="roundRect">
-            <a:avLst/>
-          </a:prstGeom>
-        </p:spPr>
-        <p:style>
-          <a:lnRef idx="2">
-            <a:schemeClr val="accent4">
-              <a:shade val="15000"/>
-            </a:schemeClr>
-          </a:lnRef>
-          <a:fillRef idx="1">
-            <a:schemeClr val="accent4"/>
-          </a:fillRef>
-          <a:effectRef idx="0">
-            <a:schemeClr val="accent4"/>
-          </a:effectRef>
-          <a:fontRef idx="minor">
-            <a:schemeClr val="lt1"/>
-          </a:fontRef>
-        </p:style>
-        <p:txBody>
-          <a:bodyPr rtlCol="0" anchor="ctr"/>
-          <a:lstStyle/>
-          <a:p>
-            <a:pPr algn="ctr"/>
-            <a:r>
-              <a:rPr lang="de-DE" dirty="0"/>
-              <a:t>Average </a:t>
-            </a:r>
-            <a:r>
-              <a:rPr lang="de-DE" dirty="0" err="1"/>
-              <a:t>of</a:t>
-            </a:r>
-            <a:r>
-              <a:rPr lang="de-DE" dirty="0"/>
-              <a:t> </a:t>
-            </a:r>
-            <a:r>
-              <a:rPr lang="de-DE" dirty="0" err="1"/>
-              <a:t>target</a:t>
-            </a:r>
-            <a:r>
-              <a:rPr lang="de-DE" dirty="0"/>
-              <a:t> </a:t>
-            </a:r>
-            <a:r>
-              <a:rPr lang="de-DE" dirty="0" err="1"/>
-              <a:t>points</a:t>
-            </a:r>
-            <a:endParaRPr lang="en-US" dirty="0"/>
-          </a:p>
-        </p:txBody>
-      </p:sp>
-      <p:sp>
-        <p:nvSpPr>
-          <p:cNvPr id="18" name="Rectangle: Rounded Corners 17">
-            <a:extLst>
-              <a:ext uri="{FF2B5EF4-FFF2-40B4-BE49-F238E27FC236}">
-                <a16:creationId xmlns:a16="http://schemas.microsoft.com/office/drawing/2014/main" id="{A740DFA0-4CF8-7F77-7532-0124F09DB0CE}"/>
-              </a:ext>
-            </a:extLst>
-          </p:cNvPr>
-          <p:cNvSpPr/>
-          <p:nvPr/>
-        </p:nvSpPr>
-        <p:spPr>
-          <a:xfrm>
-            <a:off x="9114631" y="7410907"/>
-            <a:ext cx="2114550" cy="590550"/>
-          </a:xfrm>
-          <a:prstGeom prst="roundRect">
-            <a:avLst/>
-          </a:prstGeom>
-          <a:solidFill>
-            <a:schemeClr val="accent2">
-              <a:lumMod val="40000"/>
-              <a:lumOff val="60000"/>
-            </a:schemeClr>
-          </a:solidFill>
-        </p:spPr>
-        <p:style>
-          <a:lnRef idx="2">
-            <a:schemeClr val="accent1">
-              <a:shade val="15000"/>
-            </a:schemeClr>
-          </a:lnRef>
-          <a:fillRef idx="1">
-            <a:schemeClr val="accent1"/>
-          </a:fillRef>
-          <a:effectRef idx="0">
-            <a:schemeClr val="accent1"/>
-          </a:effectRef>
-          <a:fontRef idx="minor">
-            <a:schemeClr val="lt1"/>
-          </a:fontRef>
-        </p:style>
-        <p:txBody>
-          <a:bodyPr rtlCol="0" anchor="ctr"/>
-          <a:lstStyle/>
-          <a:p>
-            <a:pPr algn="ctr"/>
-            <a:r>
-              <a:rPr lang="de-DE" dirty="0"/>
-              <a:t>Ecoder1 </a:t>
-            </a:r>
-            <a:r>
-              <a:rPr lang="de-DE" dirty="0" err="1"/>
-              <a:t>Conv</a:t>
-            </a:r>
-            <a:endParaRPr lang="en-US" dirty="0"/>
-          </a:p>
-        </p:txBody>
-      </p:sp>
-      <p:sp>
-        <p:nvSpPr>
-          <p:cNvPr id="20" name="Rectangle: Rounded Corners 19">
-            <a:extLst>
-              <a:ext uri="{FF2B5EF4-FFF2-40B4-BE49-F238E27FC236}">
-                <a16:creationId xmlns:a16="http://schemas.microsoft.com/office/drawing/2014/main" id="{C912CE24-DDA6-417C-3C3D-F20A861E6C91}"/>
-              </a:ext>
-            </a:extLst>
-          </p:cNvPr>
-          <p:cNvSpPr/>
-          <p:nvPr/>
-        </p:nvSpPr>
-        <p:spPr>
-          <a:xfrm>
-            <a:off x="9438481" y="8369975"/>
-            <a:ext cx="2114550" cy="590550"/>
-          </a:xfrm>
-          <a:prstGeom prst="roundRect">
-            <a:avLst/>
-          </a:prstGeom>
-          <a:solidFill>
-            <a:schemeClr val="accent2">
-              <a:lumMod val="40000"/>
-              <a:lumOff val="60000"/>
-            </a:schemeClr>
-          </a:solidFill>
-        </p:spPr>
-        <p:style>
-          <a:lnRef idx="2">
-            <a:schemeClr val="accent1">
-              <a:shade val="15000"/>
-            </a:schemeClr>
-          </a:lnRef>
-          <a:fillRef idx="1">
-            <a:schemeClr val="accent1"/>
-          </a:fillRef>
-          <a:effectRef idx="0">
-            <a:schemeClr val="accent1"/>
-          </a:effectRef>
-          <a:fontRef idx="minor">
-            <a:schemeClr val="lt1"/>
-          </a:fontRef>
-        </p:style>
-        <p:txBody>
-          <a:bodyPr rtlCol="0" anchor="ctr"/>
-          <a:lstStyle/>
-          <a:p>
-            <a:pPr algn="ctr"/>
-            <a:r>
-              <a:rPr lang="de-DE" dirty="0"/>
-              <a:t>Ecoder2 </a:t>
-            </a:r>
-            <a:r>
-              <a:rPr lang="de-DE" dirty="0" err="1"/>
-              <a:t>Conv</a:t>
-            </a:r>
-            <a:endParaRPr lang="en-US" dirty="0"/>
-          </a:p>
-        </p:txBody>
-      </p:sp>
-      <p:sp>
-        <p:nvSpPr>
-          <p:cNvPr id="22" name="Rectangle: Rounded Corners 21">
-            <a:extLst>
-              <a:ext uri="{FF2B5EF4-FFF2-40B4-BE49-F238E27FC236}">
-                <a16:creationId xmlns:a16="http://schemas.microsoft.com/office/drawing/2014/main" id="{9820254A-C7F8-9604-55FF-FA715AE18E17}"/>
-              </a:ext>
-            </a:extLst>
-          </p:cNvPr>
-          <p:cNvSpPr/>
-          <p:nvPr/>
-        </p:nvSpPr>
-        <p:spPr>
-          <a:xfrm>
-            <a:off x="11149806" y="9407763"/>
-            <a:ext cx="2114550" cy="590550"/>
-          </a:xfrm>
-          <a:prstGeom prst="roundRect">
-            <a:avLst/>
-          </a:prstGeom>
-          <a:solidFill>
-            <a:schemeClr val="accent2">
-              <a:lumMod val="40000"/>
-              <a:lumOff val="60000"/>
-            </a:schemeClr>
-          </a:solidFill>
-        </p:spPr>
-        <p:style>
-          <a:lnRef idx="2">
-            <a:schemeClr val="accent1">
-              <a:shade val="15000"/>
-            </a:schemeClr>
-          </a:lnRef>
-          <a:fillRef idx="1">
-            <a:schemeClr val="accent1"/>
-          </a:fillRef>
-          <a:effectRef idx="0">
-            <a:schemeClr val="accent1"/>
-          </a:effectRef>
-          <a:fontRef idx="minor">
-            <a:schemeClr val="lt1"/>
-          </a:fontRef>
-        </p:style>
-        <p:txBody>
-          <a:bodyPr rtlCol="0" anchor="ctr"/>
-          <a:lstStyle/>
-          <a:p>
-            <a:pPr algn="ctr"/>
-            <a:r>
-              <a:rPr lang="de-DE" dirty="0"/>
-              <a:t>Bottleneck</a:t>
-            </a:r>
-            <a:endParaRPr lang="en-US" dirty="0"/>
-          </a:p>
-        </p:txBody>
-      </p:sp>
-      <p:sp>
-        <p:nvSpPr>
-          <p:cNvPr id="24" name="Rectangle: Rounded Corners 23">
-            <a:extLst>
-              <a:ext uri="{FF2B5EF4-FFF2-40B4-BE49-F238E27FC236}">
-                <a16:creationId xmlns:a16="http://schemas.microsoft.com/office/drawing/2014/main" id="{336D44A0-3E0D-0418-596C-9C599A075DF2}"/>
-              </a:ext>
-            </a:extLst>
-          </p:cNvPr>
-          <p:cNvSpPr/>
-          <p:nvPr/>
-        </p:nvSpPr>
-        <p:spPr>
-          <a:xfrm>
-            <a:off x="12861131" y="8369975"/>
-            <a:ext cx="2114550" cy="590550"/>
-          </a:xfrm>
-          <a:prstGeom prst="roundRect">
-            <a:avLst/>
-          </a:prstGeom>
-          <a:solidFill>
-            <a:schemeClr val="accent2">
-              <a:lumMod val="40000"/>
-              <a:lumOff val="60000"/>
-            </a:schemeClr>
-          </a:solidFill>
-        </p:spPr>
-        <p:style>
-          <a:lnRef idx="2">
-            <a:schemeClr val="accent1">
-              <a:shade val="15000"/>
-            </a:schemeClr>
-          </a:lnRef>
-          <a:fillRef idx="1">
-            <a:schemeClr val="accent1"/>
-          </a:fillRef>
-          <a:effectRef idx="0">
-            <a:schemeClr val="accent1"/>
-          </a:effectRef>
-          <a:fontRef idx="minor">
-            <a:schemeClr val="lt1"/>
-          </a:fontRef>
-        </p:style>
-        <p:txBody>
-          <a:bodyPr rtlCol="0" anchor="ctr"/>
-          <a:lstStyle/>
-          <a:p>
-            <a:pPr algn="ctr"/>
-            <a:r>
-              <a:rPr lang="de-DE" dirty="0"/>
-              <a:t>Decoder1 </a:t>
-            </a:r>
-            <a:r>
-              <a:rPr lang="de-DE" dirty="0" err="1"/>
-              <a:t>Conv</a:t>
-            </a:r>
-            <a:endParaRPr lang="en-US" dirty="0"/>
-          </a:p>
-        </p:txBody>
-      </p:sp>
-      <p:sp>
-        <p:nvSpPr>
-          <p:cNvPr id="26" name="Rectangle: Rounded Corners 25">
-            <a:extLst>
-              <a:ext uri="{FF2B5EF4-FFF2-40B4-BE49-F238E27FC236}">
-                <a16:creationId xmlns:a16="http://schemas.microsoft.com/office/drawing/2014/main" id="{D515C0DD-D3E2-7208-6D6A-28FA704876BE}"/>
-              </a:ext>
-            </a:extLst>
-          </p:cNvPr>
-          <p:cNvSpPr/>
-          <p:nvPr/>
-        </p:nvSpPr>
-        <p:spPr>
-          <a:xfrm>
-            <a:off x="12981781" y="7410907"/>
-            <a:ext cx="2114550" cy="590550"/>
-          </a:xfrm>
-          <a:prstGeom prst="roundRect">
-            <a:avLst/>
-          </a:prstGeom>
-          <a:solidFill>
-            <a:schemeClr val="accent2">
-              <a:lumMod val="40000"/>
-              <a:lumOff val="60000"/>
-            </a:schemeClr>
-          </a:solidFill>
-        </p:spPr>
-        <p:style>
-          <a:lnRef idx="2">
-            <a:schemeClr val="accent1">
-              <a:shade val="15000"/>
-            </a:schemeClr>
-          </a:lnRef>
-          <a:fillRef idx="1">
-            <a:schemeClr val="accent1"/>
-          </a:fillRef>
-          <a:effectRef idx="0">
-            <a:schemeClr val="accent1"/>
-          </a:effectRef>
-          <a:fontRef idx="minor">
-            <a:schemeClr val="lt1"/>
-          </a:fontRef>
-        </p:style>
-        <p:txBody>
-          <a:bodyPr rtlCol="0" anchor="ctr"/>
-          <a:lstStyle/>
-          <a:p>
-            <a:pPr algn="ctr"/>
-            <a:r>
-              <a:rPr lang="de-DE" dirty="0"/>
-              <a:t>Decoder2 </a:t>
-            </a:r>
-            <a:r>
-              <a:rPr lang="de-DE" dirty="0" err="1"/>
-              <a:t>Conv</a:t>
-            </a:r>
-            <a:endParaRPr lang="en-US" dirty="0"/>
-          </a:p>
-        </p:txBody>
-      </p:sp>
-      <p:sp>
-        <p:nvSpPr>
-          <p:cNvPr id="28" name="Rectangle: Rounded Corners 27">
-            <a:extLst>
-              <a:ext uri="{FF2B5EF4-FFF2-40B4-BE49-F238E27FC236}">
-                <a16:creationId xmlns:a16="http://schemas.microsoft.com/office/drawing/2014/main" id="{966072AF-AB69-671B-4D26-AA4052C6DE69}"/>
-              </a:ext>
-            </a:extLst>
-          </p:cNvPr>
-          <p:cNvSpPr/>
-          <p:nvPr/>
-        </p:nvSpPr>
-        <p:spPr>
-          <a:xfrm>
-            <a:off x="9385140" y="11796613"/>
-            <a:ext cx="5176679" cy="590550"/>
-          </a:xfrm>
-          <a:prstGeom prst="roundRect">
-            <a:avLst/>
-          </a:prstGeom>
-          <a:solidFill>
-            <a:schemeClr val="accent3">
-              <a:lumMod val="40000"/>
-              <a:lumOff val="60000"/>
-            </a:schemeClr>
-          </a:solidFill>
-        </p:spPr>
-        <p:style>
-          <a:lnRef idx="2">
-            <a:schemeClr val="accent1">
-              <a:shade val="15000"/>
-            </a:schemeClr>
-          </a:lnRef>
-          <a:fillRef idx="1">
-            <a:schemeClr val="accent1"/>
-          </a:fillRef>
-          <a:effectRef idx="0">
-            <a:schemeClr val="accent1"/>
-          </a:effectRef>
-          <a:fontRef idx="minor">
-            <a:schemeClr val="lt1"/>
-          </a:fontRef>
-        </p:style>
-        <p:txBody>
-          <a:bodyPr rtlCol="0" anchor="ctr"/>
-          <a:lstStyle/>
-          <a:p>
-            <a:pPr algn="ctr"/>
-            <a:r>
-              <a:rPr lang="de-DE" dirty="0"/>
-              <a:t>MLP-Layer</a:t>
-            </a:r>
-            <a:endParaRPr lang="en-US" dirty="0"/>
-          </a:p>
-        </p:txBody>
-      </p:sp>
-      <p:cxnSp>
-        <p:nvCxnSpPr>
-          <p:cNvPr id="30" name="Connector: Elbow 29">
-            <a:extLst>
-              <a:ext uri="{FF2B5EF4-FFF2-40B4-BE49-F238E27FC236}">
-                <a16:creationId xmlns:a16="http://schemas.microsoft.com/office/drawing/2014/main" id="{6B405D43-A9AE-6D60-DF02-FCB1CB2022F8}"/>
-              </a:ext>
-            </a:extLst>
-          </p:cNvPr>
-          <p:cNvCxnSpPr>
-            <a:endCxn id="12" idx="1"/>
-          </p:cNvCxnSpPr>
-          <p:nvPr/>
-        </p:nvCxnSpPr>
-        <p:spPr>
-          <a:xfrm>
-            <a:off x="3718560" y="8602980"/>
-            <a:ext cx="363698" cy="65345"/>
-          </a:xfrm>
-          <a:prstGeom prst="bentConnector3">
-            <a:avLst>
-              <a:gd name="adj1" fmla="val 49999"/>
-            </a:avLst>
-          </a:prstGeom>
-          <a:ln>
-            <a:tailEnd type="triangle"/>
-          </a:ln>
-        </p:spPr>
-        <p:style>
-          <a:lnRef idx="2">
-            <a:schemeClr val="accent1"/>
-          </a:lnRef>
-          <a:fillRef idx="0">
-            <a:schemeClr val="accent1"/>
-          </a:fillRef>
-          <a:effectRef idx="1">
-            <a:schemeClr val="accent1"/>
-          </a:effectRef>
-          <a:fontRef idx="minor">
-            <a:schemeClr val="tx1"/>
-          </a:fontRef>
-        </p:style>
-      </p:cxnSp>
-      <p:cxnSp>
-        <p:nvCxnSpPr>
-          <p:cNvPr id="31" name="Connector: Elbow 30">
-            <a:extLst>
-              <a:ext uri="{FF2B5EF4-FFF2-40B4-BE49-F238E27FC236}">
-                <a16:creationId xmlns:a16="http://schemas.microsoft.com/office/drawing/2014/main" id="{225F65EE-5C1F-B244-EFB6-07F268E67D52}"/>
-              </a:ext>
-            </a:extLst>
-          </p:cNvPr>
-          <p:cNvCxnSpPr/>
-          <p:nvPr/>
-        </p:nvCxnSpPr>
-        <p:spPr>
-          <a:xfrm>
-            <a:off x="3743801" y="9203492"/>
-            <a:ext cx="363698" cy="65345"/>
-          </a:xfrm>
-          <a:prstGeom prst="bentConnector3">
-            <a:avLst/>
-          </a:prstGeom>
-          <a:ln>
-            <a:tailEnd type="triangle"/>
-          </a:ln>
-        </p:spPr>
-        <p:style>
-          <a:lnRef idx="2">
-            <a:schemeClr val="accent1"/>
-          </a:lnRef>
-          <a:fillRef idx="0">
-            <a:schemeClr val="accent1"/>
-          </a:fillRef>
-          <a:effectRef idx="1">
-            <a:schemeClr val="accent1"/>
-          </a:effectRef>
-          <a:fontRef idx="minor">
-            <a:schemeClr val="tx1"/>
-          </a:fontRef>
-        </p:style>
-      </p:cxnSp>
-      <p:cxnSp>
-        <p:nvCxnSpPr>
-          <p:cNvPr id="32" name="Connector: Elbow 31">
-            <a:extLst>
-              <a:ext uri="{FF2B5EF4-FFF2-40B4-BE49-F238E27FC236}">
-                <a16:creationId xmlns:a16="http://schemas.microsoft.com/office/drawing/2014/main" id="{BC63E6CC-2F80-1EB4-1DA3-369A00180BE8}"/>
-              </a:ext>
-            </a:extLst>
-          </p:cNvPr>
-          <p:cNvCxnSpPr/>
-          <p:nvPr/>
-        </p:nvCxnSpPr>
-        <p:spPr>
-          <a:xfrm>
-            <a:off x="3688397" y="9769763"/>
-            <a:ext cx="363698" cy="65345"/>
-          </a:xfrm>
-          <a:prstGeom prst="bentConnector3">
-            <a:avLst/>
-          </a:prstGeom>
-          <a:ln>
-            <a:tailEnd type="triangle"/>
-          </a:ln>
-        </p:spPr>
-        <p:style>
-          <a:lnRef idx="2">
-            <a:schemeClr val="accent1"/>
-          </a:lnRef>
-          <a:fillRef idx="0">
-            <a:schemeClr val="accent1"/>
-          </a:fillRef>
-          <a:effectRef idx="1">
-            <a:schemeClr val="accent1"/>
-          </a:effectRef>
-          <a:fontRef idx="minor">
-            <a:schemeClr val="tx1"/>
-          </a:fontRef>
-        </p:style>
-      </p:cxnSp>
-      <p:cxnSp>
-        <p:nvCxnSpPr>
-          <p:cNvPr id="33" name="Connector: Elbow 32">
-            <a:extLst>
-              <a:ext uri="{FF2B5EF4-FFF2-40B4-BE49-F238E27FC236}">
-                <a16:creationId xmlns:a16="http://schemas.microsoft.com/office/drawing/2014/main" id="{153B07A2-9BBB-2CE0-7E45-8130C0266498}"/>
-              </a:ext>
-            </a:extLst>
-          </p:cNvPr>
-          <p:cNvCxnSpPr>
-            <a:cxnSpLocks/>
-            <a:stCxn id="12" idx="3"/>
-            <a:endCxn id="18" idx="1"/>
-          </p:cNvCxnSpPr>
-          <p:nvPr/>
-        </p:nvCxnSpPr>
-        <p:spPr>
-          <a:xfrm flipV="1">
-            <a:off x="7177883" y="7706182"/>
-            <a:ext cx="1936748" cy="962143"/>
-          </a:xfrm>
-          <a:prstGeom prst="bentConnector3">
-            <a:avLst>
-              <a:gd name="adj1" fmla="val 50000"/>
-            </a:avLst>
-          </a:prstGeom>
-          <a:ln>
-            <a:tailEnd type="triangle"/>
-          </a:ln>
-        </p:spPr>
-        <p:style>
-          <a:lnRef idx="2">
-            <a:schemeClr val="accent1"/>
-          </a:lnRef>
-          <a:fillRef idx="0">
-            <a:schemeClr val="accent1"/>
-          </a:fillRef>
-          <a:effectRef idx="1">
-            <a:schemeClr val="accent1"/>
-          </a:effectRef>
-          <a:fontRef idx="minor">
-            <a:schemeClr val="tx1"/>
-          </a:fontRef>
-        </p:style>
-      </p:cxnSp>
-      <p:cxnSp>
-        <p:nvCxnSpPr>
-          <p:cNvPr id="37" name="Connector: Elbow 36">
-            <a:extLst>
-              <a:ext uri="{FF2B5EF4-FFF2-40B4-BE49-F238E27FC236}">
-                <a16:creationId xmlns:a16="http://schemas.microsoft.com/office/drawing/2014/main" id="{A8F02EAF-1EC9-9D5C-1258-431DC5983249}"/>
-              </a:ext>
-            </a:extLst>
-          </p:cNvPr>
-          <p:cNvCxnSpPr>
-            <a:cxnSpLocks/>
-            <a:stCxn id="14" idx="3"/>
-            <a:endCxn id="18" idx="1"/>
-          </p:cNvCxnSpPr>
-          <p:nvPr/>
-        </p:nvCxnSpPr>
-        <p:spPr>
-          <a:xfrm flipV="1">
-            <a:off x="7177883" y="7706182"/>
-            <a:ext cx="1936748" cy="1528414"/>
-          </a:xfrm>
-          <a:prstGeom prst="bentConnector3">
-            <a:avLst/>
-          </a:prstGeom>
-          <a:ln>
-            <a:tailEnd type="triangle"/>
-          </a:ln>
-        </p:spPr>
-        <p:style>
-          <a:lnRef idx="2">
-            <a:schemeClr val="accent1"/>
-          </a:lnRef>
-          <a:fillRef idx="0">
-            <a:schemeClr val="accent1"/>
-          </a:fillRef>
-          <a:effectRef idx="1">
-            <a:schemeClr val="accent1"/>
-          </a:effectRef>
-          <a:fontRef idx="minor">
-            <a:schemeClr val="tx1"/>
-          </a:fontRef>
-        </p:style>
-      </p:cxnSp>
-      <p:cxnSp>
-        <p:nvCxnSpPr>
-          <p:cNvPr id="39" name="Connector: Elbow 38">
-            <a:extLst>
-              <a:ext uri="{FF2B5EF4-FFF2-40B4-BE49-F238E27FC236}">
-                <a16:creationId xmlns:a16="http://schemas.microsoft.com/office/drawing/2014/main" id="{8D08AE09-4804-B81A-C35D-EAE0CE8232BB}"/>
-              </a:ext>
-            </a:extLst>
-          </p:cNvPr>
-          <p:cNvCxnSpPr>
-            <a:cxnSpLocks/>
-            <a:stCxn id="16" idx="3"/>
-            <a:endCxn id="18" idx="1"/>
-          </p:cNvCxnSpPr>
-          <p:nvPr/>
-        </p:nvCxnSpPr>
-        <p:spPr>
-          <a:xfrm flipV="1">
-            <a:off x="7177883" y="7706182"/>
-            <a:ext cx="1936748" cy="2112077"/>
-          </a:xfrm>
-          <a:prstGeom prst="bentConnector3">
-            <a:avLst>
-              <a:gd name="adj1" fmla="val 50000"/>
-            </a:avLst>
-          </a:prstGeom>
-          <a:ln>
-            <a:tailEnd type="triangle"/>
-          </a:ln>
-        </p:spPr>
-        <p:style>
-          <a:lnRef idx="2">
-            <a:schemeClr val="accent1"/>
-          </a:lnRef>
-          <a:fillRef idx="0">
-            <a:schemeClr val="accent1"/>
-          </a:fillRef>
-          <a:effectRef idx="1">
-            <a:schemeClr val="accent1"/>
-          </a:effectRef>
-          <a:fontRef idx="minor">
-            <a:schemeClr val="tx1"/>
-          </a:fontRef>
-        </p:style>
-      </p:cxnSp>
-      <p:cxnSp>
-        <p:nvCxnSpPr>
-          <p:cNvPr id="42" name="Connector: Elbow 41">
-            <a:extLst>
-              <a:ext uri="{FF2B5EF4-FFF2-40B4-BE49-F238E27FC236}">
-                <a16:creationId xmlns:a16="http://schemas.microsoft.com/office/drawing/2014/main" id="{4A145CE0-3A8A-A9BF-F6E5-19782977AF5D}"/>
-              </a:ext>
-            </a:extLst>
-          </p:cNvPr>
-          <p:cNvCxnSpPr>
-            <a:cxnSpLocks/>
-            <a:stCxn id="18" idx="2"/>
-            <a:endCxn id="20" idx="0"/>
-          </p:cNvCxnSpPr>
-          <p:nvPr/>
-        </p:nvCxnSpPr>
-        <p:spPr>
-          <a:xfrm rot="16200000" flipH="1">
-            <a:off x="10149572" y="8023791"/>
-            <a:ext cx="368518" cy="323850"/>
-          </a:xfrm>
-          <a:prstGeom prst="bentConnector3">
-            <a:avLst>
-              <a:gd name="adj1" fmla="val 50000"/>
-            </a:avLst>
-          </a:prstGeom>
-          <a:ln>
-            <a:tailEnd type="triangle"/>
-          </a:ln>
-        </p:spPr>
-        <p:style>
-          <a:lnRef idx="2">
-            <a:schemeClr val="accent1"/>
-          </a:lnRef>
-          <a:fillRef idx="0">
-            <a:schemeClr val="accent1"/>
-          </a:fillRef>
-          <a:effectRef idx="1">
-            <a:schemeClr val="accent1"/>
-          </a:effectRef>
-          <a:fontRef idx="minor">
-            <a:schemeClr val="tx1"/>
-          </a:fontRef>
-        </p:style>
-      </p:cxnSp>
-      <p:cxnSp>
-        <p:nvCxnSpPr>
-          <p:cNvPr id="45" name="Connector: Elbow 44">
-            <a:extLst>
-              <a:ext uri="{FF2B5EF4-FFF2-40B4-BE49-F238E27FC236}">
-                <a16:creationId xmlns:a16="http://schemas.microsoft.com/office/drawing/2014/main" id="{8A82F017-584D-1D6A-E3A4-6E72846174B6}"/>
-              </a:ext>
-            </a:extLst>
-          </p:cNvPr>
-          <p:cNvCxnSpPr>
-            <a:cxnSpLocks/>
-            <a:stCxn id="20" idx="2"/>
-            <a:endCxn id="22" idx="0"/>
-          </p:cNvCxnSpPr>
-          <p:nvPr/>
-        </p:nvCxnSpPr>
-        <p:spPr>
-          <a:xfrm rot="16200000" flipH="1">
-            <a:off x="11127799" y="8328481"/>
-            <a:ext cx="447238" cy="1711325"/>
-          </a:xfrm>
-          <a:prstGeom prst="bentConnector3">
-            <a:avLst>
-              <a:gd name="adj1" fmla="val 50000"/>
-            </a:avLst>
-          </a:prstGeom>
-          <a:ln>
-            <a:tailEnd type="triangle"/>
-          </a:ln>
-        </p:spPr>
-        <p:style>
-          <a:lnRef idx="2">
-            <a:schemeClr val="accent1"/>
-          </a:lnRef>
-          <a:fillRef idx="0">
-            <a:schemeClr val="accent1"/>
-          </a:fillRef>
-          <a:effectRef idx="1">
-            <a:schemeClr val="accent1"/>
-          </a:effectRef>
-          <a:fontRef idx="minor">
-            <a:schemeClr val="tx1"/>
-          </a:fontRef>
-        </p:style>
-      </p:cxnSp>
-      <p:cxnSp>
-        <p:nvCxnSpPr>
-          <p:cNvPr id="48" name="Connector: Elbow 47">
-            <a:extLst>
-              <a:ext uri="{FF2B5EF4-FFF2-40B4-BE49-F238E27FC236}">
-                <a16:creationId xmlns:a16="http://schemas.microsoft.com/office/drawing/2014/main" id="{CBA1EC98-CA28-B007-069E-0FD5C03CBBA2}"/>
-              </a:ext>
-            </a:extLst>
-          </p:cNvPr>
-          <p:cNvCxnSpPr>
-            <a:cxnSpLocks/>
-            <a:stCxn id="22" idx="2"/>
-            <a:endCxn id="24" idx="2"/>
-          </p:cNvCxnSpPr>
-          <p:nvPr/>
-        </p:nvCxnSpPr>
-        <p:spPr>
-          <a:xfrm rot="5400000" flipH="1" flipV="1">
-            <a:off x="12543849" y="8623756"/>
-            <a:ext cx="1037788" cy="1711325"/>
-          </a:xfrm>
-          <a:prstGeom prst="bentConnector3">
-            <a:avLst>
-              <a:gd name="adj1" fmla="val -22028"/>
-            </a:avLst>
-          </a:prstGeom>
-          <a:ln>
-            <a:tailEnd type="triangle"/>
-          </a:ln>
-        </p:spPr>
-        <p:style>
-          <a:lnRef idx="2">
-            <a:schemeClr val="accent1"/>
-          </a:lnRef>
-          <a:fillRef idx="0">
-            <a:schemeClr val="accent1"/>
-          </a:fillRef>
-          <a:effectRef idx="1">
-            <a:schemeClr val="accent1"/>
-          </a:effectRef>
-          <a:fontRef idx="minor">
-            <a:schemeClr val="tx1"/>
-          </a:fontRef>
-        </p:style>
-      </p:cxnSp>
-      <p:cxnSp>
-        <p:nvCxnSpPr>
-          <p:cNvPr id="51" name="Connector: Elbow 50">
-            <a:extLst>
-              <a:ext uri="{FF2B5EF4-FFF2-40B4-BE49-F238E27FC236}">
-                <a16:creationId xmlns:a16="http://schemas.microsoft.com/office/drawing/2014/main" id="{6C60505A-6629-AC93-BAA3-05F62B894044}"/>
-              </a:ext>
-            </a:extLst>
-          </p:cNvPr>
-          <p:cNvCxnSpPr>
-            <a:cxnSpLocks/>
-            <a:stCxn id="24" idx="0"/>
-            <a:endCxn id="26" idx="2"/>
-          </p:cNvCxnSpPr>
-          <p:nvPr/>
-        </p:nvCxnSpPr>
-        <p:spPr>
-          <a:xfrm rot="5400000" flipH="1" flipV="1">
-            <a:off x="13794472" y="8125391"/>
-            <a:ext cx="368518" cy="120650"/>
-          </a:xfrm>
-          <a:prstGeom prst="bentConnector3">
-            <a:avLst>
-              <a:gd name="adj1" fmla="val 50000"/>
-            </a:avLst>
-          </a:prstGeom>
-          <a:ln>
-            <a:tailEnd type="triangle"/>
-          </a:ln>
-        </p:spPr>
-        <p:style>
-          <a:lnRef idx="2">
-            <a:schemeClr val="accent1"/>
-          </a:lnRef>
-          <a:fillRef idx="0">
-            <a:schemeClr val="accent1"/>
-          </a:fillRef>
-          <a:effectRef idx="1">
-            <a:schemeClr val="accent1"/>
-          </a:effectRef>
-          <a:fontRef idx="minor">
-            <a:schemeClr val="tx1"/>
-          </a:fontRef>
-        </p:style>
-      </p:cxnSp>
-      <p:cxnSp>
-        <p:nvCxnSpPr>
-          <p:cNvPr id="54" name="Connector: Elbow 53">
-            <a:extLst>
-              <a:ext uri="{FF2B5EF4-FFF2-40B4-BE49-F238E27FC236}">
-                <a16:creationId xmlns:a16="http://schemas.microsoft.com/office/drawing/2014/main" id="{45FDC0EF-70FA-E531-9CD4-80B31124B0CD}"/>
-              </a:ext>
-            </a:extLst>
-          </p:cNvPr>
-          <p:cNvCxnSpPr>
-            <a:cxnSpLocks/>
-            <a:stCxn id="26" idx="3"/>
-            <a:endCxn id="28" idx="0"/>
-          </p:cNvCxnSpPr>
-          <p:nvPr/>
-        </p:nvCxnSpPr>
-        <p:spPr>
-          <a:xfrm flipH="1">
-            <a:off x="11973480" y="7706182"/>
-            <a:ext cx="3122851" cy="4090431"/>
-          </a:xfrm>
-          <a:prstGeom prst="bentConnector4">
-            <a:avLst>
-              <a:gd name="adj1" fmla="val -7320"/>
-              <a:gd name="adj2" fmla="val 75777"/>
-            </a:avLst>
-          </a:prstGeom>
-          <a:ln>
-            <a:tailEnd type="triangle"/>
-          </a:ln>
-        </p:spPr>
-        <p:style>
-          <a:lnRef idx="2">
-            <a:schemeClr val="accent1"/>
-          </a:lnRef>
-          <a:fillRef idx="0">
-            <a:schemeClr val="accent1"/>
-          </a:fillRef>
-          <a:effectRef idx="1">
-            <a:schemeClr val="accent1"/>
-          </a:effectRef>
-          <a:fontRef idx="minor">
-            <a:schemeClr val="tx1"/>
-          </a:fontRef>
-        </p:style>
-      </p:cxnSp>
-      <p:cxnSp>
-        <p:nvCxnSpPr>
-          <p:cNvPr id="61" name="Straight Arrow Connector 60">
-            <a:extLst>
-              <a:ext uri="{FF2B5EF4-FFF2-40B4-BE49-F238E27FC236}">
-                <a16:creationId xmlns:a16="http://schemas.microsoft.com/office/drawing/2014/main" id="{28483BE7-9C25-2BA9-613C-E911B872D9CD}"/>
-              </a:ext>
-            </a:extLst>
-          </p:cNvPr>
-          <p:cNvCxnSpPr>
-            <a:cxnSpLocks/>
-            <a:stCxn id="28" idx="2"/>
-          </p:cNvCxnSpPr>
-          <p:nvPr/>
-        </p:nvCxnSpPr>
-        <p:spPr>
-          <a:xfrm flipH="1">
-            <a:off x="11973479" y="12387163"/>
-            <a:ext cx="1" cy="929156"/>
-          </a:xfrm>
-          <a:prstGeom prst="straightConnector1">
-            <a:avLst/>
-          </a:prstGeom>
-          <a:ln>
-            <a:tailEnd type="triangle"/>
-          </a:ln>
-        </p:spPr>
-        <p:style>
-          <a:lnRef idx="2">
-            <a:schemeClr val="accent1"/>
-          </a:lnRef>
-          <a:fillRef idx="0">
-            <a:schemeClr val="accent1"/>
-          </a:fillRef>
-          <a:effectRef idx="1">
-            <a:schemeClr val="accent1"/>
-          </a:effectRef>
-          <a:fontRef idx="minor">
-            <a:schemeClr val="tx1"/>
-          </a:fontRef>
-        </p:style>
-      </p:cxnSp>
-      <p:sp>
-        <p:nvSpPr>
-          <p:cNvPr id="66" name="TextBox 65">
-            <a:extLst>
-              <a:ext uri="{FF2B5EF4-FFF2-40B4-BE49-F238E27FC236}">
-                <a16:creationId xmlns:a16="http://schemas.microsoft.com/office/drawing/2014/main" id="{1EEB77A4-F975-13A5-FA7D-59FAC0730808}"/>
-              </a:ext>
-            </a:extLst>
-          </p:cNvPr>
-          <p:cNvSpPr txBox="1"/>
-          <p:nvPr/>
-        </p:nvSpPr>
-        <p:spPr>
-          <a:xfrm>
-            <a:off x="8679180" y="6393180"/>
-            <a:ext cx="2004060" cy="369332"/>
-          </a:xfrm>
-          <a:prstGeom prst="rect">
-            <a:avLst/>
-          </a:prstGeom>
-          <a:noFill/>
-        </p:spPr>
-        <p:txBody>
-          <a:bodyPr wrap="square" rtlCol="0">
-            <a:spAutoFit/>
-          </a:bodyPr>
-          <a:lstStyle/>
-          <a:p>
-            <a:r>
-              <a:rPr lang="de-DE" dirty="0" err="1"/>
-              <a:t>Unet</a:t>
-            </a:r>
-            <a:r>
-              <a:rPr lang="de-DE" dirty="0"/>
-              <a:t> Architecture</a:t>
-            </a:r>
-            <a:endParaRPr lang="en-US" dirty="0"/>
-          </a:p>
-        </p:txBody>
-      </p:sp>
+        </p:grpSpPr>
+        <p:sp>
+          <p:nvSpPr>
+            <p:cNvPr id="65" name="Rectangle 64">
+              <a:extLst>
+                <a:ext uri="{FF2B5EF4-FFF2-40B4-BE49-F238E27FC236}">
+                  <a16:creationId xmlns:a16="http://schemas.microsoft.com/office/drawing/2014/main" id="{01AF2AA7-E939-63CC-38CE-0F455AD5F781}"/>
+                </a:ext>
+              </a:extLst>
+            </p:cNvPr>
+            <p:cNvSpPr/>
+            <p:nvPr/>
+          </p:nvSpPr>
+          <p:spPr>
+            <a:xfrm>
+              <a:off x="8602980" y="6324600"/>
+              <a:ext cx="7254240" cy="4808220"/>
+            </a:xfrm>
+            <a:prstGeom prst="rect">
+              <a:avLst/>
+            </a:prstGeom>
+            <a:solidFill>
+              <a:schemeClr val="accent2">
+                <a:lumMod val="20000"/>
+                <a:lumOff val="80000"/>
+              </a:schemeClr>
+            </a:solidFill>
+          </p:spPr>
+          <p:style>
+            <a:lnRef idx="2">
+              <a:schemeClr val="accent1">
+                <a:shade val="15000"/>
+              </a:schemeClr>
+            </a:lnRef>
+            <a:fillRef idx="1">
+              <a:schemeClr val="accent1"/>
+            </a:fillRef>
+            <a:effectRef idx="0">
+              <a:schemeClr val="accent1"/>
+            </a:effectRef>
+            <a:fontRef idx="minor">
+              <a:schemeClr val="lt1"/>
+            </a:fontRef>
+          </p:style>
+          <p:txBody>
+            <a:bodyPr rtlCol="0" anchor="ctr"/>
+            <a:lstStyle/>
+            <a:p>
+              <a:pPr algn="ctr"/>
+              <a:endParaRPr lang="en-US"/>
+            </a:p>
+          </p:txBody>
+        </p:sp>
+        <p:sp>
+          <p:nvSpPr>
+            <p:cNvPr id="4" name="Rectangle 3">
+              <a:extLst>
+                <a:ext uri="{FF2B5EF4-FFF2-40B4-BE49-F238E27FC236}">
+                  <a16:creationId xmlns:a16="http://schemas.microsoft.com/office/drawing/2014/main" id="{70DC31C1-FA46-0D7F-E303-4BD17E035EC7}"/>
+                </a:ext>
+              </a:extLst>
+            </p:cNvPr>
+            <p:cNvSpPr/>
+            <p:nvPr/>
+          </p:nvSpPr>
+          <p:spPr>
+            <a:xfrm>
+              <a:off x="3971131" y="7528560"/>
+              <a:ext cx="4489450" cy="2652897"/>
+            </a:xfrm>
+            <a:prstGeom prst="rect">
+              <a:avLst/>
+            </a:prstGeom>
+          </p:spPr>
+          <p:style>
+            <a:lnRef idx="2">
+              <a:schemeClr val="accent4">
+                <a:shade val="15000"/>
+              </a:schemeClr>
+            </a:lnRef>
+            <a:fillRef idx="1">
+              <a:schemeClr val="accent4"/>
+            </a:fillRef>
+            <a:effectRef idx="0">
+              <a:schemeClr val="accent4"/>
+            </a:effectRef>
+            <a:fontRef idx="minor">
+              <a:schemeClr val="lt1"/>
+            </a:fontRef>
+          </p:style>
+          <p:txBody>
+            <a:bodyPr rtlCol="0" anchor="ctr"/>
+            <a:lstStyle/>
+            <a:p>
+              <a:pPr algn="ctr"/>
+              <a:endParaRPr lang="en-US" dirty="0"/>
+            </a:p>
+          </p:txBody>
+        </p:sp>
+        <p:sp>
+          <p:nvSpPr>
+            <p:cNvPr id="5" name="TextBox 4">
+              <a:extLst>
+                <a:ext uri="{FF2B5EF4-FFF2-40B4-BE49-F238E27FC236}">
+                  <a16:creationId xmlns:a16="http://schemas.microsoft.com/office/drawing/2014/main" id="{3AE7CCFB-A858-9B6F-947E-A59670379913}"/>
+                </a:ext>
+              </a:extLst>
+            </p:cNvPr>
+            <p:cNvSpPr txBox="1"/>
+            <p:nvPr/>
+          </p:nvSpPr>
+          <p:spPr>
+            <a:xfrm>
+              <a:off x="4037649" y="7605132"/>
+              <a:ext cx="1606550" cy="2186496"/>
+            </a:xfrm>
+            <a:prstGeom prst="rect">
+              <a:avLst/>
+            </a:prstGeom>
+            <a:noFill/>
+          </p:spPr>
+          <p:txBody>
+            <a:bodyPr wrap="square" rtlCol="0">
+              <a:spAutoFit/>
+            </a:bodyPr>
+            <a:lstStyle/>
+            <a:p>
+              <a:r>
+                <a:rPr lang="de-DE" dirty="0"/>
+                <a:t>Data </a:t>
+              </a:r>
+              <a:r>
+                <a:rPr lang="de-DE" dirty="0" err="1"/>
+                <a:t>preprocessing</a:t>
+              </a:r>
+              <a:endParaRPr lang="en-US" dirty="0"/>
+            </a:p>
+          </p:txBody>
+        </p:sp>
+        <p:sp>
+          <p:nvSpPr>
+            <p:cNvPr id="7" name="TextBox 6">
+              <a:extLst>
+                <a:ext uri="{FF2B5EF4-FFF2-40B4-BE49-F238E27FC236}">
+                  <a16:creationId xmlns:a16="http://schemas.microsoft.com/office/drawing/2014/main" id="{4A0C5739-595D-3E81-DD57-3725F7D75297}"/>
+                </a:ext>
+              </a:extLst>
+            </p:cNvPr>
+            <p:cNvSpPr txBox="1"/>
+            <p:nvPr/>
+          </p:nvSpPr>
+          <p:spPr>
+            <a:xfrm>
+              <a:off x="2590006" y="8395712"/>
+              <a:ext cx="1606550" cy="1139414"/>
+            </a:xfrm>
+            <a:prstGeom prst="rect">
+              <a:avLst/>
+            </a:prstGeom>
+            <a:noFill/>
+          </p:spPr>
+          <p:txBody>
+            <a:bodyPr wrap="square" rtlCol="0">
+              <a:spAutoFit/>
+            </a:bodyPr>
+            <a:lstStyle/>
+            <a:p>
+              <a:r>
+                <a:rPr lang="de-DE" dirty="0" err="1"/>
+                <a:t>Trajectory</a:t>
+              </a:r>
+              <a:endParaRPr lang="en-US" dirty="0"/>
+            </a:p>
+          </p:txBody>
+        </p:sp>
+        <p:sp>
+          <p:nvSpPr>
+            <p:cNvPr id="9" name="TextBox 8">
+              <a:extLst>
+                <a:ext uri="{FF2B5EF4-FFF2-40B4-BE49-F238E27FC236}">
+                  <a16:creationId xmlns:a16="http://schemas.microsoft.com/office/drawing/2014/main" id="{F40563CF-072F-E4D6-903C-71F7AF434E24}"/>
+                </a:ext>
+              </a:extLst>
+            </p:cNvPr>
+            <p:cNvSpPr txBox="1"/>
+            <p:nvPr/>
+          </p:nvSpPr>
+          <p:spPr>
+            <a:xfrm>
+              <a:off x="2590006" y="9042043"/>
+              <a:ext cx="1606550" cy="1139414"/>
+            </a:xfrm>
+            <a:prstGeom prst="rect">
+              <a:avLst/>
+            </a:prstGeom>
+            <a:noFill/>
+          </p:spPr>
+          <p:txBody>
+            <a:bodyPr wrap="square" rtlCol="0">
+              <a:spAutoFit/>
+            </a:bodyPr>
+            <a:lstStyle/>
+            <a:p>
+              <a:r>
+                <a:rPr lang="de-DE" dirty="0"/>
+                <a:t>Flow Time</a:t>
+              </a:r>
+              <a:endParaRPr lang="en-US" dirty="0"/>
+            </a:p>
+          </p:txBody>
+        </p:sp>
+        <p:sp>
+          <p:nvSpPr>
+            <p:cNvPr id="11" name="TextBox 10">
+              <a:extLst>
+                <a:ext uri="{FF2B5EF4-FFF2-40B4-BE49-F238E27FC236}">
+                  <a16:creationId xmlns:a16="http://schemas.microsoft.com/office/drawing/2014/main" id="{EBDC45EB-39EF-6615-63A5-F919F37261F5}"/>
+                </a:ext>
+              </a:extLst>
+            </p:cNvPr>
+            <p:cNvSpPr txBox="1"/>
+            <p:nvPr/>
+          </p:nvSpPr>
+          <p:spPr>
+            <a:xfrm>
+              <a:off x="2590005" y="9541450"/>
+              <a:ext cx="1606551" cy="646331"/>
+            </a:xfrm>
+            <a:prstGeom prst="rect">
+              <a:avLst/>
+            </a:prstGeom>
+            <a:noFill/>
+          </p:spPr>
+          <p:txBody>
+            <a:bodyPr wrap="square" rtlCol="0">
+              <a:spAutoFit/>
+            </a:bodyPr>
+            <a:lstStyle/>
+            <a:p>
+              <a:r>
+                <a:rPr lang="de-DE" dirty="0"/>
+                <a:t>Target </a:t>
+              </a:r>
+            </a:p>
+            <a:p>
+              <a:r>
+                <a:rPr lang="de-DE" dirty="0"/>
+                <a:t>Shape</a:t>
+              </a:r>
+              <a:endParaRPr lang="en-US" dirty="0"/>
+            </a:p>
+          </p:txBody>
+        </p:sp>
+        <p:sp>
+          <p:nvSpPr>
+            <p:cNvPr id="12" name="Rectangle: Rounded Corners 11">
+              <a:extLst>
+                <a:ext uri="{FF2B5EF4-FFF2-40B4-BE49-F238E27FC236}">
+                  <a16:creationId xmlns:a16="http://schemas.microsoft.com/office/drawing/2014/main" id="{002551A4-7F36-810E-C8AB-CD2E41541AF8}"/>
+                </a:ext>
+              </a:extLst>
+            </p:cNvPr>
+            <p:cNvSpPr/>
+            <p:nvPr/>
+          </p:nvSpPr>
+          <p:spPr>
+            <a:xfrm>
+              <a:off x="4082258" y="8441531"/>
+              <a:ext cx="3095625" cy="453588"/>
+            </a:xfrm>
+            <a:prstGeom prst="roundRect">
+              <a:avLst/>
+            </a:prstGeom>
+          </p:spPr>
+          <p:style>
+            <a:lnRef idx="2">
+              <a:schemeClr val="accent4">
+                <a:shade val="15000"/>
+              </a:schemeClr>
+            </a:lnRef>
+            <a:fillRef idx="1">
+              <a:schemeClr val="accent4"/>
+            </a:fillRef>
+            <a:effectRef idx="0">
+              <a:schemeClr val="accent4"/>
+            </a:effectRef>
+            <a:fontRef idx="minor">
+              <a:schemeClr val="lt1"/>
+            </a:fontRef>
+          </p:style>
+          <p:txBody>
+            <a:bodyPr rtlCol="0" anchor="ctr"/>
+            <a:lstStyle/>
+            <a:p>
+              <a:pPr algn="ctr"/>
+              <a:r>
+                <a:rPr lang="de-DE" dirty="0" err="1"/>
+                <a:t>Convolutional</a:t>
+              </a:r>
+              <a:r>
+                <a:rPr lang="de-DE" dirty="0"/>
+                <a:t> </a:t>
+              </a:r>
+              <a:r>
+                <a:rPr lang="de-DE" dirty="0" err="1"/>
+                <a:t>encoding</a:t>
+              </a:r>
+              <a:endParaRPr lang="en-US" dirty="0"/>
+            </a:p>
+          </p:txBody>
+        </p:sp>
+        <p:sp>
+          <p:nvSpPr>
+            <p:cNvPr id="14" name="Rectangle: Rounded Corners 13">
+              <a:extLst>
+                <a:ext uri="{FF2B5EF4-FFF2-40B4-BE49-F238E27FC236}">
+                  <a16:creationId xmlns:a16="http://schemas.microsoft.com/office/drawing/2014/main" id="{64294990-7F7B-F473-747B-8E46DE35AA70}"/>
+                </a:ext>
+              </a:extLst>
+            </p:cNvPr>
+            <p:cNvSpPr/>
+            <p:nvPr/>
+          </p:nvSpPr>
+          <p:spPr>
+            <a:xfrm>
+              <a:off x="4082258" y="9007802"/>
+              <a:ext cx="3095625" cy="453588"/>
+            </a:xfrm>
+            <a:prstGeom prst="roundRect">
+              <a:avLst/>
+            </a:prstGeom>
+          </p:spPr>
+          <p:style>
+            <a:lnRef idx="2">
+              <a:schemeClr val="accent4">
+                <a:shade val="15000"/>
+              </a:schemeClr>
+            </a:lnRef>
+            <a:fillRef idx="1">
+              <a:schemeClr val="accent4"/>
+            </a:fillRef>
+            <a:effectRef idx="0">
+              <a:schemeClr val="accent4"/>
+            </a:effectRef>
+            <a:fontRef idx="minor">
+              <a:schemeClr val="lt1"/>
+            </a:fontRef>
+          </p:style>
+          <p:txBody>
+            <a:bodyPr rtlCol="0" anchor="ctr"/>
+            <a:lstStyle/>
+            <a:p>
+              <a:pPr algn="ctr"/>
+              <a:r>
+                <a:rPr lang="de-DE" dirty="0" err="1"/>
+                <a:t>Sinusoidal</a:t>
+              </a:r>
+              <a:r>
+                <a:rPr lang="de-DE" dirty="0"/>
+                <a:t> Time </a:t>
+              </a:r>
+              <a:r>
+                <a:rPr lang="de-DE" dirty="0" err="1"/>
+                <a:t>embedding</a:t>
+              </a:r>
+              <a:endParaRPr lang="en-US" dirty="0"/>
+            </a:p>
+          </p:txBody>
+        </p:sp>
+        <p:sp>
+          <p:nvSpPr>
+            <p:cNvPr id="16" name="Rectangle: Rounded Corners 15">
+              <a:extLst>
+                <a:ext uri="{FF2B5EF4-FFF2-40B4-BE49-F238E27FC236}">
+                  <a16:creationId xmlns:a16="http://schemas.microsoft.com/office/drawing/2014/main" id="{71F7D8A1-4909-A92A-67C4-B1214D3AC981}"/>
+                </a:ext>
+              </a:extLst>
+            </p:cNvPr>
+            <p:cNvSpPr/>
+            <p:nvPr/>
+          </p:nvSpPr>
+          <p:spPr>
+            <a:xfrm>
+              <a:off x="4082258" y="9591465"/>
+              <a:ext cx="3095625" cy="453588"/>
+            </a:xfrm>
+            <a:prstGeom prst="roundRect">
+              <a:avLst/>
+            </a:prstGeom>
+          </p:spPr>
+          <p:style>
+            <a:lnRef idx="2">
+              <a:schemeClr val="accent4">
+                <a:shade val="15000"/>
+              </a:schemeClr>
+            </a:lnRef>
+            <a:fillRef idx="1">
+              <a:schemeClr val="accent4"/>
+            </a:fillRef>
+            <a:effectRef idx="0">
+              <a:schemeClr val="accent4"/>
+            </a:effectRef>
+            <a:fontRef idx="minor">
+              <a:schemeClr val="lt1"/>
+            </a:fontRef>
+          </p:style>
+          <p:txBody>
+            <a:bodyPr rtlCol="0" anchor="ctr"/>
+            <a:lstStyle/>
+            <a:p>
+              <a:pPr algn="ctr"/>
+              <a:r>
+                <a:rPr lang="de-DE" dirty="0"/>
+                <a:t>Average </a:t>
+              </a:r>
+              <a:r>
+                <a:rPr lang="de-DE" dirty="0" err="1"/>
+                <a:t>of</a:t>
+              </a:r>
+              <a:r>
+                <a:rPr lang="de-DE" dirty="0"/>
+                <a:t> </a:t>
+              </a:r>
+              <a:r>
+                <a:rPr lang="de-DE" dirty="0" err="1"/>
+                <a:t>target</a:t>
+              </a:r>
+              <a:r>
+                <a:rPr lang="de-DE" dirty="0"/>
+                <a:t> </a:t>
+              </a:r>
+              <a:r>
+                <a:rPr lang="de-DE" dirty="0" err="1"/>
+                <a:t>points</a:t>
+              </a:r>
+              <a:endParaRPr lang="en-US" dirty="0"/>
+            </a:p>
+          </p:txBody>
+        </p:sp>
+        <p:sp>
+          <p:nvSpPr>
+            <p:cNvPr id="18" name="Rectangle: Rounded Corners 17">
+              <a:extLst>
+                <a:ext uri="{FF2B5EF4-FFF2-40B4-BE49-F238E27FC236}">
+                  <a16:creationId xmlns:a16="http://schemas.microsoft.com/office/drawing/2014/main" id="{A740DFA0-4CF8-7F77-7532-0124F09DB0CE}"/>
+                </a:ext>
+              </a:extLst>
+            </p:cNvPr>
+            <p:cNvSpPr/>
+            <p:nvPr/>
+          </p:nvSpPr>
+          <p:spPr>
+            <a:xfrm>
+              <a:off x="9114631" y="7410907"/>
+              <a:ext cx="2114550" cy="590550"/>
+            </a:xfrm>
+            <a:prstGeom prst="roundRect">
+              <a:avLst/>
+            </a:prstGeom>
+            <a:solidFill>
+              <a:schemeClr val="accent2">
+                <a:lumMod val="40000"/>
+                <a:lumOff val="60000"/>
+              </a:schemeClr>
+            </a:solidFill>
+          </p:spPr>
+          <p:style>
+            <a:lnRef idx="2">
+              <a:schemeClr val="accent1">
+                <a:shade val="15000"/>
+              </a:schemeClr>
+            </a:lnRef>
+            <a:fillRef idx="1">
+              <a:schemeClr val="accent1"/>
+            </a:fillRef>
+            <a:effectRef idx="0">
+              <a:schemeClr val="accent1"/>
+            </a:effectRef>
+            <a:fontRef idx="minor">
+              <a:schemeClr val="lt1"/>
+            </a:fontRef>
+          </p:style>
+          <p:txBody>
+            <a:bodyPr rtlCol="0" anchor="ctr"/>
+            <a:lstStyle/>
+            <a:p>
+              <a:pPr algn="ctr"/>
+              <a:r>
+                <a:rPr lang="de-DE" dirty="0"/>
+                <a:t>Ecoder1 </a:t>
+              </a:r>
+              <a:r>
+                <a:rPr lang="de-DE" dirty="0" err="1"/>
+                <a:t>Conv</a:t>
+              </a:r>
+              <a:endParaRPr lang="en-US" dirty="0"/>
+            </a:p>
+          </p:txBody>
+        </p:sp>
+        <p:sp>
+          <p:nvSpPr>
+            <p:cNvPr id="20" name="Rectangle: Rounded Corners 19">
+              <a:extLst>
+                <a:ext uri="{FF2B5EF4-FFF2-40B4-BE49-F238E27FC236}">
+                  <a16:creationId xmlns:a16="http://schemas.microsoft.com/office/drawing/2014/main" id="{C912CE24-DDA6-417C-3C3D-F20A861E6C91}"/>
+                </a:ext>
+              </a:extLst>
+            </p:cNvPr>
+            <p:cNvSpPr/>
+            <p:nvPr/>
+          </p:nvSpPr>
+          <p:spPr>
+            <a:xfrm>
+              <a:off x="9438481" y="8369975"/>
+              <a:ext cx="2114550" cy="590550"/>
+            </a:xfrm>
+            <a:prstGeom prst="roundRect">
+              <a:avLst/>
+            </a:prstGeom>
+            <a:solidFill>
+              <a:schemeClr val="accent2">
+                <a:lumMod val="40000"/>
+                <a:lumOff val="60000"/>
+              </a:schemeClr>
+            </a:solidFill>
+          </p:spPr>
+          <p:style>
+            <a:lnRef idx="2">
+              <a:schemeClr val="accent1">
+                <a:shade val="15000"/>
+              </a:schemeClr>
+            </a:lnRef>
+            <a:fillRef idx="1">
+              <a:schemeClr val="accent1"/>
+            </a:fillRef>
+            <a:effectRef idx="0">
+              <a:schemeClr val="accent1"/>
+            </a:effectRef>
+            <a:fontRef idx="minor">
+              <a:schemeClr val="lt1"/>
+            </a:fontRef>
+          </p:style>
+          <p:txBody>
+            <a:bodyPr rtlCol="0" anchor="ctr"/>
+            <a:lstStyle/>
+            <a:p>
+              <a:pPr algn="ctr"/>
+              <a:r>
+                <a:rPr lang="de-DE" dirty="0"/>
+                <a:t>Ecoder2 </a:t>
+              </a:r>
+              <a:r>
+                <a:rPr lang="de-DE" dirty="0" err="1"/>
+                <a:t>Conv</a:t>
+              </a:r>
+              <a:endParaRPr lang="en-US" dirty="0"/>
+            </a:p>
+          </p:txBody>
+        </p:sp>
+        <p:sp>
+          <p:nvSpPr>
+            <p:cNvPr id="22" name="Rectangle: Rounded Corners 21">
+              <a:extLst>
+                <a:ext uri="{FF2B5EF4-FFF2-40B4-BE49-F238E27FC236}">
+                  <a16:creationId xmlns:a16="http://schemas.microsoft.com/office/drawing/2014/main" id="{9820254A-C7F8-9604-55FF-FA715AE18E17}"/>
+                </a:ext>
+              </a:extLst>
+            </p:cNvPr>
+            <p:cNvSpPr/>
+            <p:nvPr/>
+          </p:nvSpPr>
+          <p:spPr>
+            <a:xfrm>
+              <a:off x="11149806" y="9407763"/>
+              <a:ext cx="2114550" cy="590550"/>
+            </a:xfrm>
+            <a:prstGeom prst="roundRect">
+              <a:avLst/>
+            </a:prstGeom>
+            <a:solidFill>
+              <a:schemeClr val="accent2">
+                <a:lumMod val="40000"/>
+                <a:lumOff val="60000"/>
+              </a:schemeClr>
+            </a:solidFill>
+          </p:spPr>
+          <p:style>
+            <a:lnRef idx="2">
+              <a:schemeClr val="accent1">
+                <a:shade val="15000"/>
+              </a:schemeClr>
+            </a:lnRef>
+            <a:fillRef idx="1">
+              <a:schemeClr val="accent1"/>
+            </a:fillRef>
+            <a:effectRef idx="0">
+              <a:schemeClr val="accent1"/>
+            </a:effectRef>
+            <a:fontRef idx="minor">
+              <a:schemeClr val="lt1"/>
+            </a:fontRef>
+          </p:style>
+          <p:txBody>
+            <a:bodyPr rtlCol="0" anchor="ctr"/>
+            <a:lstStyle/>
+            <a:p>
+              <a:pPr algn="ctr"/>
+              <a:r>
+                <a:rPr lang="de-DE" dirty="0"/>
+                <a:t>Bottleneck</a:t>
+              </a:r>
+              <a:endParaRPr lang="en-US" dirty="0"/>
+            </a:p>
+          </p:txBody>
+        </p:sp>
+        <p:sp>
+          <p:nvSpPr>
+            <p:cNvPr id="24" name="Rectangle: Rounded Corners 23">
+              <a:extLst>
+                <a:ext uri="{FF2B5EF4-FFF2-40B4-BE49-F238E27FC236}">
+                  <a16:creationId xmlns:a16="http://schemas.microsoft.com/office/drawing/2014/main" id="{336D44A0-3E0D-0418-596C-9C599A075DF2}"/>
+                </a:ext>
+              </a:extLst>
+            </p:cNvPr>
+            <p:cNvSpPr/>
+            <p:nvPr/>
+          </p:nvSpPr>
+          <p:spPr>
+            <a:xfrm>
+              <a:off x="12861131" y="8369975"/>
+              <a:ext cx="2114550" cy="590550"/>
+            </a:xfrm>
+            <a:prstGeom prst="roundRect">
+              <a:avLst/>
+            </a:prstGeom>
+            <a:solidFill>
+              <a:schemeClr val="accent2">
+                <a:lumMod val="40000"/>
+                <a:lumOff val="60000"/>
+              </a:schemeClr>
+            </a:solidFill>
+          </p:spPr>
+          <p:style>
+            <a:lnRef idx="2">
+              <a:schemeClr val="accent1">
+                <a:shade val="15000"/>
+              </a:schemeClr>
+            </a:lnRef>
+            <a:fillRef idx="1">
+              <a:schemeClr val="accent1"/>
+            </a:fillRef>
+            <a:effectRef idx="0">
+              <a:schemeClr val="accent1"/>
+            </a:effectRef>
+            <a:fontRef idx="minor">
+              <a:schemeClr val="lt1"/>
+            </a:fontRef>
+          </p:style>
+          <p:txBody>
+            <a:bodyPr rtlCol="0" anchor="ctr"/>
+            <a:lstStyle/>
+            <a:p>
+              <a:pPr algn="ctr"/>
+              <a:r>
+                <a:rPr lang="de-DE" dirty="0"/>
+                <a:t>Decoder1 </a:t>
+              </a:r>
+              <a:r>
+                <a:rPr lang="de-DE" dirty="0" err="1"/>
+                <a:t>Conv</a:t>
+              </a:r>
+              <a:endParaRPr lang="en-US" dirty="0"/>
+            </a:p>
+          </p:txBody>
+        </p:sp>
+        <p:sp>
+          <p:nvSpPr>
+            <p:cNvPr id="26" name="Rectangle: Rounded Corners 25">
+              <a:extLst>
+                <a:ext uri="{FF2B5EF4-FFF2-40B4-BE49-F238E27FC236}">
+                  <a16:creationId xmlns:a16="http://schemas.microsoft.com/office/drawing/2014/main" id="{D515C0DD-D3E2-7208-6D6A-28FA704876BE}"/>
+                </a:ext>
+              </a:extLst>
+            </p:cNvPr>
+            <p:cNvSpPr/>
+            <p:nvPr/>
+          </p:nvSpPr>
+          <p:spPr>
+            <a:xfrm>
+              <a:off x="12981781" y="7410907"/>
+              <a:ext cx="2114550" cy="590550"/>
+            </a:xfrm>
+            <a:prstGeom prst="roundRect">
+              <a:avLst/>
+            </a:prstGeom>
+            <a:solidFill>
+              <a:schemeClr val="accent2">
+                <a:lumMod val="40000"/>
+                <a:lumOff val="60000"/>
+              </a:schemeClr>
+            </a:solidFill>
+          </p:spPr>
+          <p:style>
+            <a:lnRef idx="2">
+              <a:schemeClr val="accent1">
+                <a:shade val="15000"/>
+              </a:schemeClr>
+            </a:lnRef>
+            <a:fillRef idx="1">
+              <a:schemeClr val="accent1"/>
+            </a:fillRef>
+            <a:effectRef idx="0">
+              <a:schemeClr val="accent1"/>
+            </a:effectRef>
+            <a:fontRef idx="minor">
+              <a:schemeClr val="lt1"/>
+            </a:fontRef>
+          </p:style>
+          <p:txBody>
+            <a:bodyPr rtlCol="0" anchor="ctr"/>
+            <a:lstStyle/>
+            <a:p>
+              <a:pPr algn="ctr"/>
+              <a:r>
+                <a:rPr lang="de-DE" dirty="0"/>
+                <a:t>Decoder2 </a:t>
+              </a:r>
+              <a:r>
+                <a:rPr lang="de-DE" dirty="0" err="1"/>
+                <a:t>Conv</a:t>
+              </a:r>
+              <a:endParaRPr lang="en-US" dirty="0"/>
+            </a:p>
+          </p:txBody>
+        </p:sp>
+        <p:sp>
+          <p:nvSpPr>
+            <p:cNvPr id="28" name="Rectangle: Rounded Corners 27">
+              <a:extLst>
+                <a:ext uri="{FF2B5EF4-FFF2-40B4-BE49-F238E27FC236}">
+                  <a16:creationId xmlns:a16="http://schemas.microsoft.com/office/drawing/2014/main" id="{966072AF-AB69-671B-4D26-AA4052C6DE69}"/>
+                </a:ext>
+              </a:extLst>
+            </p:cNvPr>
+            <p:cNvSpPr/>
+            <p:nvPr/>
+          </p:nvSpPr>
+          <p:spPr>
+            <a:xfrm>
+              <a:off x="9385140" y="11796613"/>
+              <a:ext cx="5176679" cy="590550"/>
+            </a:xfrm>
+            <a:prstGeom prst="roundRect">
+              <a:avLst/>
+            </a:prstGeom>
+            <a:solidFill>
+              <a:schemeClr val="accent3">
+                <a:lumMod val="40000"/>
+                <a:lumOff val="60000"/>
+              </a:schemeClr>
+            </a:solidFill>
+          </p:spPr>
+          <p:style>
+            <a:lnRef idx="2">
+              <a:schemeClr val="accent1">
+                <a:shade val="15000"/>
+              </a:schemeClr>
+            </a:lnRef>
+            <a:fillRef idx="1">
+              <a:schemeClr val="accent1"/>
+            </a:fillRef>
+            <a:effectRef idx="0">
+              <a:schemeClr val="accent1"/>
+            </a:effectRef>
+            <a:fontRef idx="minor">
+              <a:schemeClr val="lt1"/>
+            </a:fontRef>
+          </p:style>
+          <p:txBody>
+            <a:bodyPr rtlCol="0" anchor="ctr"/>
+            <a:lstStyle/>
+            <a:p>
+              <a:pPr algn="ctr"/>
+              <a:r>
+                <a:rPr lang="de-DE" dirty="0"/>
+                <a:t>MLP-Layer</a:t>
+              </a:r>
+              <a:endParaRPr lang="en-US" dirty="0"/>
+            </a:p>
+          </p:txBody>
+        </p:sp>
+        <p:cxnSp>
+          <p:nvCxnSpPr>
+            <p:cNvPr id="30" name="Connector: Elbow 29">
+              <a:extLst>
+                <a:ext uri="{FF2B5EF4-FFF2-40B4-BE49-F238E27FC236}">
+                  <a16:creationId xmlns:a16="http://schemas.microsoft.com/office/drawing/2014/main" id="{6B405D43-A9AE-6D60-DF02-FCB1CB2022F8}"/>
+                </a:ext>
+              </a:extLst>
+            </p:cNvPr>
+            <p:cNvCxnSpPr>
+              <a:endCxn id="12" idx="1"/>
+            </p:cNvCxnSpPr>
+            <p:nvPr/>
+          </p:nvCxnSpPr>
+          <p:spPr>
+            <a:xfrm>
+              <a:off x="3718560" y="8602980"/>
+              <a:ext cx="363698" cy="65345"/>
+            </a:xfrm>
+            <a:prstGeom prst="bentConnector3">
+              <a:avLst>
+                <a:gd name="adj1" fmla="val 49999"/>
+              </a:avLst>
+            </a:prstGeom>
+            <a:ln>
+              <a:tailEnd type="triangle"/>
+            </a:ln>
+          </p:spPr>
+          <p:style>
+            <a:lnRef idx="2">
+              <a:schemeClr val="accent1"/>
+            </a:lnRef>
+            <a:fillRef idx="0">
+              <a:schemeClr val="accent1"/>
+            </a:fillRef>
+            <a:effectRef idx="1">
+              <a:schemeClr val="accent1"/>
+            </a:effectRef>
+            <a:fontRef idx="minor">
+              <a:schemeClr val="tx1"/>
+            </a:fontRef>
+          </p:style>
+        </p:cxnSp>
+        <p:cxnSp>
+          <p:nvCxnSpPr>
+            <p:cNvPr id="31" name="Connector: Elbow 30">
+              <a:extLst>
+                <a:ext uri="{FF2B5EF4-FFF2-40B4-BE49-F238E27FC236}">
+                  <a16:creationId xmlns:a16="http://schemas.microsoft.com/office/drawing/2014/main" id="{225F65EE-5C1F-B244-EFB6-07F268E67D52}"/>
+                </a:ext>
+              </a:extLst>
+            </p:cNvPr>
+            <p:cNvCxnSpPr/>
+            <p:nvPr/>
+          </p:nvCxnSpPr>
+          <p:spPr>
+            <a:xfrm>
+              <a:off x="3743801" y="9203492"/>
+              <a:ext cx="363698" cy="65345"/>
+            </a:xfrm>
+            <a:prstGeom prst="bentConnector3">
+              <a:avLst/>
+            </a:prstGeom>
+            <a:ln>
+              <a:tailEnd type="triangle"/>
+            </a:ln>
+          </p:spPr>
+          <p:style>
+            <a:lnRef idx="2">
+              <a:schemeClr val="accent1"/>
+            </a:lnRef>
+            <a:fillRef idx="0">
+              <a:schemeClr val="accent1"/>
+            </a:fillRef>
+            <a:effectRef idx="1">
+              <a:schemeClr val="accent1"/>
+            </a:effectRef>
+            <a:fontRef idx="minor">
+              <a:schemeClr val="tx1"/>
+            </a:fontRef>
+          </p:style>
+        </p:cxnSp>
+        <p:cxnSp>
+          <p:nvCxnSpPr>
+            <p:cNvPr id="32" name="Connector: Elbow 31">
+              <a:extLst>
+                <a:ext uri="{FF2B5EF4-FFF2-40B4-BE49-F238E27FC236}">
+                  <a16:creationId xmlns:a16="http://schemas.microsoft.com/office/drawing/2014/main" id="{BC63E6CC-2F80-1EB4-1DA3-369A00180BE8}"/>
+                </a:ext>
+              </a:extLst>
+            </p:cNvPr>
+            <p:cNvCxnSpPr/>
+            <p:nvPr/>
+          </p:nvCxnSpPr>
+          <p:spPr>
+            <a:xfrm>
+              <a:off x="3688397" y="9769763"/>
+              <a:ext cx="363698" cy="65345"/>
+            </a:xfrm>
+            <a:prstGeom prst="bentConnector3">
+              <a:avLst/>
+            </a:prstGeom>
+            <a:ln>
+              <a:tailEnd type="triangle"/>
+            </a:ln>
+          </p:spPr>
+          <p:style>
+            <a:lnRef idx="2">
+              <a:schemeClr val="accent1"/>
+            </a:lnRef>
+            <a:fillRef idx="0">
+              <a:schemeClr val="accent1"/>
+            </a:fillRef>
+            <a:effectRef idx="1">
+              <a:schemeClr val="accent1"/>
+            </a:effectRef>
+            <a:fontRef idx="minor">
+              <a:schemeClr val="tx1"/>
+            </a:fontRef>
+          </p:style>
+        </p:cxnSp>
+        <p:cxnSp>
+          <p:nvCxnSpPr>
+            <p:cNvPr id="33" name="Connector: Elbow 32">
+              <a:extLst>
+                <a:ext uri="{FF2B5EF4-FFF2-40B4-BE49-F238E27FC236}">
+                  <a16:creationId xmlns:a16="http://schemas.microsoft.com/office/drawing/2014/main" id="{153B07A2-9BBB-2CE0-7E45-8130C0266498}"/>
+                </a:ext>
+              </a:extLst>
+            </p:cNvPr>
+            <p:cNvCxnSpPr>
+              <a:cxnSpLocks/>
+              <a:stCxn id="12" idx="3"/>
+              <a:endCxn id="18" idx="1"/>
+            </p:cNvCxnSpPr>
+            <p:nvPr/>
+          </p:nvCxnSpPr>
+          <p:spPr>
+            <a:xfrm flipV="1">
+              <a:off x="7177883" y="7706182"/>
+              <a:ext cx="1936748" cy="962143"/>
+            </a:xfrm>
+            <a:prstGeom prst="bentConnector3">
+              <a:avLst>
+                <a:gd name="adj1" fmla="val 50000"/>
+              </a:avLst>
+            </a:prstGeom>
+            <a:ln>
+              <a:tailEnd type="triangle"/>
+            </a:ln>
+          </p:spPr>
+          <p:style>
+            <a:lnRef idx="2">
+              <a:schemeClr val="accent1"/>
+            </a:lnRef>
+            <a:fillRef idx="0">
+              <a:schemeClr val="accent1"/>
+            </a:fillRef>
+            <a:effectRef idx="1">
+              <a:schemeClr val="accent1"/>
+            </a:effectRef>
+            <a:fontRef idx="minor">
+              <a:schemeClr val="tx1"/>
+            </a:fontRef>
+          </p:style>
+        </p:cxnSp>
+        <p:cxnSp>
+          <p:nvCxnSpPr>
+            <p:cNvPr id="37" name="Connector: Elbow 36">
+              <a:extLst>
+                <a:ext uri="{FF2B5EF4-FFF2-40B4-BE49-F238E27FC236}">
+                  <a16:creationId xmlns:a16="http://schemas.microsoft.com/office/drawing/2014/main" id="{A8F02EAF-1EC9-9D5C-1258-431DC5983249}"/>
+                </a:ext>
+              </a:extLst>
+            </p:cNvPr>
+            <p:cNvCxnSpPr>
+              <a:cxnSpLocks/>
+              <a:stCxn id="14" idx="3"/>
+              <a:endCxn id="18" idx="1"/>
+            </p:cNvCxnSpPr>
+            <p:nvPr/>
+          </p:nvCxnSpPr>
+          <p:spPr>
+            <a:xfrm flipV="1">
+              <a:off x="7177883" y="7706182"/>
+              <a:ext cx="1936748" cy="1528414"/>
+            </a:xfrm>
+            <a:prstGeom prst="bentConnector3">
+              <a:avLst/>
+            </a:prstGeom>
+            <a:ln>
+              <a:tailEnd type="triangle"/>
+            </a:ln>
+          </p:spPr>
+          <p:style>
+            <a:lnRef idx="2">
+              <a:schemeClr val="accent1"/>
+            </a:lnRef>
+            <a:fillRef idx="0">
+              <a:schemeClr val="accent1"/>
+            </a:fillRef>
+            <a:effectRef idx="1">
+              <a:schemeClr val="accent1"/>
+            </a:effectRef>
+            <a:fontRef idx="minor">
+              <a:schemeClr val="tx1"/>
+            </a:fontRef>
+          </p:style>
+        </p:cxnSp>
+        <p:cxnSp>
+          <p:nvCxnSpPr>
+            <p:cNvPr id="39" name="Connector: Elbow 38">
+              <a:extLst>
+                <a:ext uri="{FF2B5EF4-FFF2-40B4-BE49-F238E27FC236}">
+                  <a16:creationId xmlns:a16="http://schemas.microsoft.com/office/drawing/2014/main" id="{8D08AE09-4804-B81A-C35D-EAE0CE8232BB}"/>
+                </a:ext>
+              </a:extLst>
+            </p:cNvPr>
+            <p:cNvCxnSpPr>
+              <a:cxnSpLocks/>
+              <a:stCxn id="16" idx="3"/>
+              <a:endCxn id="18" idx="1"/>
+            </p:cNvCxnSpPr>
+            <p:nvPr/>
+          </p:nvCxnSpPr>
+          <p:spPr>
+            <a:xfrm flipV="1">
+              <a:off x="7177883" y="7706182"/>
+              <a:ext cx="1936748" cy="2112077"/>
+            </a:xfrm>
+            <a:prstGeom prst="bentConnector3">
+              <a:avLst>
+                <a:gd name="adj1" fmla="val 50000"/>
+              </a:avLst>
+            </a:prstGeom>
+            <a:ln>
+              <a:tailEnd type="triangle"/>
+            </a:ln>
+          </p:spPr>
+          <p:style>
+            <a:lnRef idx="2">
+              <a:schemeClr val="accent1"/>
+            </a:lnRef>
+            <a:fillRef idx="0">
+              <a:schemeClr val="accent1"/>
+            </a:fillRef>
+            <a:effectRef idx="1">
+              <a:schemeClr val="accent1"/>
+            </a:effectRef>
+            <a:fontRef idx="minor">
+              <a:schemeClr val="tx1"/>
+            </a:fontRef>
+          </p:style>
+        </p:cxnSp>
+        <p:cxnSp>
+          <p:nvCxnSpPr>
+            <p:cNvPr id="42" name="Connector: Elbow 41">
+              <a:extLst>
+                <a:ext uri="{FF2B5EF4-FFF2-40B4-BE49-F238E27FC236}">
+                  <a16:creationId xmlns:a16="http://schemas.microsoft.com/office/drawing/2014/main" id="{4A145CE0-3A8A-A9BF-F6E5-19782977AF5D}"/>
+                </a:ext>
+              </a:extLst>
+            </p:cNvPr>
+            <p:cNvCxnSpPr>
+              <a:cxnSpLocks/>
+              <a:stCxn id="18" idx="2"/>
+              <a:endCxn id="20" idx="0"/>
+            </p:cNvCxnSpPr>
+            <p:nvPr/>
+          </p:nvCxnSpPr>
+          <p:spPr>
+            <a:xfrm rot="16200000" flipH="1">
+              <a:off x="10149572" y="8023791"/>
+              <a:ext cx="368518" cy="323850"/>
+            </a:xfrm>
+            <a:prstGeom prst="bentConnector3">
+              <a:avLst>
+                <a:gd name="adj1" fmla="val 50000"/>
+              </a:avLst>
+            </a:prstGeom>
+            <a:ln>
+              <a:tailEnd type="triangle"/>
+            </a:ln>
+          </p:spPr>
+          <p:style>
+            <a:lnRef idx="2">
+              <a:schemeClr val="accent1"/>
+            </a:lnRef>
+            <a:fillRef idx="0">
+              <a:schemeClr val="accent1"/>
+            </a:fillRef>
+            <a:effectRef idx="1">
+              <a:schemeClr val="accent1"/>
+            </a:effectRef>
+            <a:fontRef idx="minor">
+              <a:schemeClr val="tx1"/>
+            </a:fontRef>
+          </p:style>
+        </p:cxnSp>
+        <p:cxnSp>
+          <p:nvCxnSpPr>
+            <p:cNvPr id="45" name="Connector: Elbow 44">
+              <a:extLst>
+                <a:ext uri="{FF2B5EF4-FFF2-40B4-BE49-F238E27FC236}">
+                  <a16:creationId xmlns:a16="http://schemas.microsoft.com/office/drawing/2014/main" id="{8A82F017-584D-1D6A-E3A4-6E72846174B6}"/>
+                </a:ext>
+              </a:extLst>
+            </p:cNvPr>
+            <p:cNvCxnSpPr>
+              <a:cxnSpLocks/>
+              <a:stCxn id="20" idx="2"/>
+              <a:endCxn id="22" idx="0"/>
+            </p:cNvCxnSpPr>
+            <p:nvPr/>
+          </p:nvCxnSpPr>
+          <p:spPr>
+            <a:xfrm rot="16200000" flipH="1">
+              <a:off x="11127799" y="8328481"/>
+              <a:ext cx="447238" cy="1711325"/>
+            </a:xfrm>
+            <a:prstGeom prst="bentConnector3">
+              <a:avLst>
+                <a:gd name="adj1" fmla="val 50000"/>
+              </a:avLst>
+            </a:prstGeom>
+            <a:ln>
+              <a:tailEnd type="triangle"/>
+            </a:ln>
+          </p:spPr>
+          <p:style>
+            <a:lnRef idx="2">
+              <a:schemeClr val="accent1"/>
+            </a:lnRef>
+            <a:fillRef idx="0">
+              <a:schemeClr val="accent1"/>
+            </a:fillRef>
+            <a:effectRef idx="1">
+              <a:schemeClr val="accent1"/>
+            </a:effectRef>
+            <a:fontRef idx="minor">
+              <a:schemeClr val="tx1"/>
+            </a:fontRef>
+          </p:style>
+        </p:cxnSp>
+        <p:cxnSp>
+          <p:nvCxnSpPr>
+            <p:cNvPr id="48" name="Connector: Elbow 47">
+              <a:extLst>
+                <a:ext uri="{FF2B5EF4-FFF2-40B4-BE49-F238E27FC236}">
+                  <a16:creationId xmlns:a16="http://schemas.microsoft.com/office/drawing/2014/main" id="{CBA1EC98-CA28-B007-069E-0FD5C03CBBA2}"/>
+                </a:ext>
+              </a:extLst>
+            </p:cNvPr>
+            <p:cNvCxnSpPr>
+              <a:cxnSpLocks/>
+              <a:stCxn id="22" idx="2"/>
+              <a:endCxn id="24" idx="2"/>
+            </p:cNvCxnSpPr>
+            <p:nvPr/>
+          </p:nvCxnSpPr>
+          <p:spPr>
+            <a:xfrm rot="5400000" flipH="1" flipV="1">
+              <a:off x="12543849" y="8623756"/>
+              <a:ext cx="1037788" cy="1711325"/>
+            </a:xfrm>
+            <a:prstGeom prst="bentConnector3">
+              <a:avLst>
+                <a:gd name="adj1" fmla="val -22028"/>
+              </a:avLst>
+            </a:prstGeom>
+            <a:ln>
+              <a:tailEnd type="triangle"/>
+            </a:ln>
+          </p:spPr>
+          <p:style>
+            <a:lnRef idx="2">
+              <a:schemeClr val="accent1"/>
+            </a:lnRef>
+            <a:fillRef idx="0">
+              <a:schemeClr val="accent1"/>
+            </a:fillRef>
+            <a:effectRef idx="1">
+              <a:schemeClr val="accent1"/>
+            </a:effectRef>
+            <a:fontRef idx="minor">
+              <a:schemeClr val="tx1"/>
+            </a:fontRef>
+          </p:style>
+        </p:cxnSp>
+        <p:cxnSp>
+          <p:nvCxnSpPr>
+            <p:cNvPr id="51" name="Connector: Elbow 50">
+              <a:extLst>
+                <a:ext uri="{FF2B5EF4-FFF2-40B4-BE49-F238E27FC236}">
+                  <a16:creationId xmlns:a16="http://schemas.microsoft.com/office/drawing/2014/main" id="{6C60505A-6629-AC93-BAA3-05F62B894044}"/>
+                </a:ext>
+              </a:extLst>
+            </p:cNvPr>
+            <p:cNvCxnSpPr>
+              <a:cxnSpLocks/>
+              <a:stCxn id="24" idx="0"/>
+              <a:endCxn id="26" idx="2"/>
+            </p:cNvCxnSpPr>
+            <p:nvPr/>
+          </p:nvCxnSpPr>
+          <p:spPr>
+            <a:xfrm rot="5400000" flipH="1" flipV="1">
+              <a:off x="13794472" y="8125391"/>
+              <a:ext cx="368518" cy="120650"/>
+            </a:xfrm>
+            <a:prstGeom prst="bentConnector3">
+              <a:avLst>
+                <a:gd name="adj1" fmla="val 50000"/>
+              </a:avLst>
+            </a:prstGeom>
+            <a:ln>
+              <a:tailEnd type="triangle"/>
+            </a:ln>
+          </p:spPr>
+          <p:style>
+            <a:lnRef idx="2">
+              <a:schemeClr val="accent1"/>
+            </a:lnRef>
+            <a:fillRef idx="0">
+              <a:schemeClr val="accent1"/>
+            </a:fillRef>
+            <a:effectRef idx="1">
+              <a:schemeClr val="accent1"/>
+            </a:effectRef>
+            <a:fontRef idx="minor">
+              <a:schemeClr val="tx1"/>
+            </a:fontRef>
+          </p:style>
+        </p:cxnSp>
+        <p:cxnSp>
+          <p:nvCxnSpPr>
+            <p:cNvPr id="54" name="Connector: Elbow 53">
+              <a:extLst>
+                <a:ext uri="{FF2B5EF4-FFF2-40B4-BE49-F238E27FC236}">
+                  <a16:creationId xmlns:a16="http://schemas.microsoft.com/office/drawing/2014/main" id="{45FDC0EF-70FA-E531-9CD4-80B31124B0CD}"/>
+                </a:ext>
+              </a:extLst>
+            </p:cNvPr>
+            <p:cNvCxnSpPr>
+              <a:cxnSpLocks/>
+              <a:stCxn id="26" idx="3"/>
+              <a:endCxn id="28" idx="0"/>
+            </p:cNvCxnSpPr>
+            <p:nvPr/>
+          </p:nvCxnSpPr>
+          <p:spPr>
+            <a:xfrm flipH="1">
+              <a:off x="11973480" y="7706182"/>
+              <a:ext cx="3122851" cy="4090431"/>
+            </a:xfrm>
+            <a:prstGeom prst="bentConnector4">
+              <a:avLst>
+                <a:gd name="adj1" fmla="val -7320"/>
+                <a:gd name="adj2" fmla="val 75777"/>
+              </a:avLst>
+            </a:prstGeom>
+            <a:ln>
+              <a:tailEnd type="triangle"/>
+            </a:ln>
+          </p:spPr>
+          <p:style>
+            <a:lnRef idx="2">
+              <a:schemeClr val="accent1"/>
+            </a:lnRef>
+            <a:fillRef idx="0">
+              <a:schemeClr val="accent1"/>
+            </a:fillRef>
+            <a:effectRef idx="1">
+              <a:schemeClr val="accent1"/>
+            </a:effectRef>
+            <a:fontRef idx="minor">
+              <a:schemeClr val="tx1"/>
+            </a:fontRef>
+          </p:style>
+        </p:cxnSp>
+        <p:cxnSp>
+          <p:nvCxnSpPr>
+            <p:cNvPr id="61" name="Straight Arrow Connector 60">
+              <a:extLst>
+                <a:ext uri="{FF2B5EF4-FFF2-40B4-BE49-F238E27FC236}">
+                  <a16:creationId xmlns:a16="http://schemas.microsoft.com/office/drawing/2014/main" id="{28483BE7-9C25-2BA9-613C-E911B872D9CD}"/>
+                </a:ext>
+              </a:extLst>
+            </p:cNvPr>
+            <p:cNvCxnSpPr>
+              <a:cxnSpLocks/>
+              <a:stCxn id="28" idx="2"/>
+            </p:cNvCxnSpPr>
+            <p:nvPr/>
+          </p:nvCxnSpPr>
+          <p:spPr>
+            <a:xfrm flipH="1">
+              <a:off x="11973479" y="12387163"/>
+              <a:ext cx="1" cy="929156"/>
+            </a:xfrm>
+            <a:prstGeom prst="straightConnector1">
+              <a:avLst/>
+            </a:prstGeom>
+            <a:ln>
+              <a:tailEnd type="triangle"/>
+            </a:ln>
+          </p:spPr>
+          <p:style>
+            <a:lnRef idx="2">
+              <a:schemeClr val="accent1"/>
+            </a:lnRef>
+            <a:fillRef idx="0">
+              <a:schemeClr val="accent1"/>
+            </a:fillRef>
+            <a:effectRef idx="1">
+              <a:schemeClr val="accent1"/>
+            </a:effectRef>
+            <a:fontRef idx="minor">
+              <a:schemeClr val="tx1"/>
+            </a:fontRef>
+          </p:style>
+        </p:cxnSp>
+        <p:sp>
+          <p:nvSpPr>
+            <p:cNvPr id="66" name="TextBox 65">
+              <a:extLst>
+                <a:ext uri="{FF2B5EF4-FFF2-40B4-BE49-F238E27FC236}">
+                  <a16:creationId xmlns:a16="http://schemas.microsoft.com/office/drawing/2014/main" id="{1EEB77A4-F975-13A5-FA7D-59FAC0730808}"/>
+                </a:ext>
+              </a:extLst>
+            </p:cNvPr>
+            <p:cNvSpPr txBox="1"/>
+            <p:nvPr/>
+          </p:nvSpPr>
+          <p:spPr>
+            <a:xfrm>
+              <a:off x="8679180" y="6393180"/>
+              <a:ext cx="2004060" cy="369332"/>
+            </a:xfrm>
+            <a:prstGeom prst="rect">
+              <a:avLst/>
+            </a:prstGeom>
+            <a:noFill/>
+          </p:spPr>
+          <p:txBody>
+            <a:bodyPr wrap="square" rtlCol="0">
+              <a:spAutoFit/>
+            </a:bodyPr>
+            <a:lstStyle/>
+            <a:p>
+              <a:r>
+                <a:rPr lang="de-DE" dirty="0" err="1"/>
+                <a:t>Unet</a:t>
+              </a:r>
+              <a:r>
+                <a:rPr lang="de-DE" dirty="0"/>
+                <a:t> Architecture</a:t>
+              </a:r>
+              <a:endParaRPr lang="en-US" dirty="0"/>
+            </a:p>
+          </p:txBody>
+        </p:sp>
+      </p:grpSp>
     </p:spTree>
     <p:extLst>
       <p:ext uri="{BB962C8B-B14F-4D97-AF65-F5344CB8AC3E}">

</xml_diff>